<commit_message>
M11: Sim-Review umgesetzt (sim_review true, Inhalt aktualisiert)
Co-Authored-By: Claude Opus 4.8 <noreply@anthropic.com>
</commit_message>
<xml_diff>
--- a/protected-downloads/praesentation/M11.pptx
+++ b/protected-downloads/praesentation/M11.pptx
@@ -8802,7 +8802,7 @@
                 </a:solidFill>
                 <a:latin typeface="Consolas"/>
               </a:rPr>
-              <a:t>30–40 min   </a:t>
+              <a:t>30–38 min   </a:t>
             </a:r>
             <a:r>
               <a:rPr sz="1500" b="1">
@@ -8839,7 +8839,7 @@
                 </a:solidFill>
                 <a:latin typeface="Consolas"/>
               </a:rPr>
-              <a:t>40–75 min   </a:t>
+              <a:t>38–78 min   </a:t>
             </a:r>
             <a:r>
               <a:rPr sz="1500" b="1">
@@ -8876,7 +8876,7 @@
                 </a:solidFill>
                 <a:latin typeface="Consolas"/>
               </a:rPr>
-              <a:t>75–85 min   </a:t>
+              <a:t>78–88 min   </a:t>
             </a:r>
             <a:r>
               <a:rPr sz="1500" b="1">
@@ -8913,7 +8913,7 @@
                 </a:solidFill>
                 <a:latin typeface="Consolas"/>
               </a:rPr>
-              <a:t>85–90 min   </a:t>
+              <a:t>88–95 min   </a:t>
             </a:r>
             <a:r>
               <a:rPr sz="1500" b="1">
@@ -8931,7 +8931,7 @@
                 </a:solidFill>
                 <a:latin typeface="Arial"/>
               </a:rPr>
-              <a:t>  ·  Einzelarbeit</a:t>
+              <a:t>  ·  Trainer-Demo + Einzelarbeit</a:t>
             </a:r>
           </a:p>
         </p:txBody>

</xml_diff>

<commit_message>
M-Track Batch 3: M11 Deck (Web/Workbook)
Co-Authored-By: Claude Fable 5 <noreply@anthropic.com>
</commit_message>
<xml_diff>
--- a/protected-downloads/praesentation/M11.pptx
+++ b/protected-downloads/praesentation/M11.pptx
@@ -17,8 +17,6 @@
     <p:sldId id="265" r:id="rId17"/>
     <p:sldId id="266" r:id="rId18"/>
     <p:sldId id="267" r:id="rId19"/>
-    <p:sldId id="268" r:id="rId20"/>
-    <p:sldId id="269" r:id="rId21"/>
   </p:sldIdLst>
   <p:sldSz cx="12188952" cy="6858000" type="screen4x3"/>
   <p:notesSz cx="6858000" cy="9144000"/>
@@ -585,7 +583,7 @@
           <a:lstStyle/>
           <a:p>
             <a:r>
-              <a:t>Siehe Trainerhandbuch (Sektion 3) für Moderationshinweise, Timing und erwartete Teilnehmerreaktionen.</a:t>
+              <a:t>Einstieg: „Wann hat ein Kunde etwas gefragt – und in Wirklichkeit etwas ganz anderes gemeint?"</a:t>
             </a:r>
           </a:p>
         </p:txBody>
@@ -655,7 +653,7 @@
           <a:lstStyle/>
           <a:p>
             <a:r>
-              <a:t>Siehe Trainerhandbuch (Sektion 3) für Moderationshinweise, Timing und erwartete Teilnehmerreaktionen.</a:t>
+              <a:t>Kunden artikulieren latente Bedarfe nicht – aus Unsicherheit, Gewohnheit oder weil sie sie selbst nicht benennen können.</a:t>
             </a:r>
           </a:p>
         </p:txBody>
@@ -725,7 +723,7 @@
           <a:lstStyle/>
           <a:p>
             <a:r>
-              <a:t>Siehe Trainerhandbuch (Sektion 3) für Moderationshinweise, Timing und erwartete Teilnehmerreaktionen.</a:t>
+              <a:t>Aktives Zuhören ist die Schlüsselkompetenz: „Was höre ich wirklich?" – die Übung im Plenum trainiert genau das.</a:t>
             </a:r>
           </a:p>
         </p:txBody>
@@ -795,7 +793,7 @@
           <a:lstStyle/>
           <a:p>
             <a:r>
-              <a:t>Siehe Trainerhandbuch (Sektion 3) für Moderationshinweise, Timing und erwartete Teilnehmerreaktionen.</a:t>
+              <a:t>Der Fall: der Kunde fragt nach dem Zins – dahinter steht eine Sorge (Liquidität, Wachstum, Nachfolge). Wer nur den Zins bearbeitet, verliert die Beratungschance.</a:t>
             </a:r>
           </a:p>
         </p:txBody>
@@ -865,12 +863,7 @@
           <a:lstStyle/>
           <a:p>
             <a:r>
-              <a:t>Auswertungshilfe (Musterlösungen – nur für Trainer/Seminarleitung)</a:t>
-            </a:r>
-          </a:p>
-          <a:p>
-            <a:r>
-              <a:t>Moderation (HB Sec 3): Fünf Aussagen aus Sec 4.3 vorlesen (oder auf Karten austeilen). TN notieren in 30 Sekunden Sachinhalt und vermuteten latenten Hintergrund. Auswertung im Plenum: Welche Aussage war am schwierigsten? Warum? Trainer-Hinweis: Aussage Nr. 1 („Die Banken geben einem ja momentan viele Angebote") hat das höchste Überraschungspotenzial – viele Berater hören zuerst nur einen allgemeinen Kommentar, nicht das Wechselsignal. Diese Aussage zum Schluss besprechen, um den Lerneffekt zu maximieren. Trainer-Hinweis Scaffolding: Bei Teilnehmenden ohne Vorerfahrung die erste Aussage gemeinsam im Plenum anhand der drei Leitfragen aus Sec 4.3 durcharbeiten (Was hat der Kunde gesagt? Welches Gefühl/welche Erfahrung steckt dahinter? Worum bittet er implizit?), bevor die übrigen fünf Aussagen in Einzelarbeit bearbeitet werden. Ohne diesen Schritt bleibt das Erkennen des latenten Hintergrunds bei unbekannten Aussagen für Einsteiger Glückssache.</a:t>
+              <a:t>Überleitung zum Selbstcheck.</a:t>
             </a:r>
           </a:p>
         </p:txBody>
@@ -940,77 +933,7 @@
           <a:lstStyle/>
           <a:p>
             <a:r>
-              <a:t>Siehe Trainerhandbuch (Sektion 3) für Moderationshinweise, Timing und erwartete Teilnehmerreaktionen.</a:t>
-            </a:r>
-          </a:p>
-        </p:txBody>
-      </p:sp>
-      <p:sp>
-        <p:nvSpPr>
-          <p:cNvPr id="4" name="Slide Number Placeholder 3"/>
-          <p:cNvSpPr>
-            <a:spLocks noGrp="1"/>
-          </p:cNvSpPr>
-          <p:nvPr>
-            <p:ph type="sldNum" idx="5" sz="quarter"/>
-          </p:nvPr>
-        </p:nvSpPr>
-        <p:spPr/>
-      </p:sp>
-    </p:spTree>
-  </p:cSld>
-  <p:clrMapOvr>
-    <a:masterClrMapping/>
-  </p:clrMapOvr>
-</p:notes>
-</file>
-
-<file path=ppt/notesSlides/notesSlide8.xml><?xml version="1.0" encoding="utf-8"?>
-<p:notes xmlns:a="http://schemas.openxmlformats.org/drawingml/2006/main" xmlns:p="http://schemas.openxmlformats.org/presentationml/2006/main" xmlns:r="http://schemas.openxmlformats.org/officeDocument/2006/relationships">
-  <p:cSld>
-    <p:spTree>
-      <p:nvGrpSpPr>
-        <p:cNvPr id="1" name=""/>
-        <p:cNvGrpSpPr/>
-        <p:nvPr/>
-      </p:nvGrpSpPr>
-      <p:grpSpPr>
-        <a:xfrm>
-          <a:off x="0" y="0"/>
-          <a:ext cx="0" cy="0"/>
-          <a:chOff x="0" y="0"/>
-          <a:chExt cx="0" cy="0"/>
-        </a:xfrm>
-      </p:grpSpPr>
-      <p:sp>
-        <p:nvSpPr>
-          <p:cNvPr id="2" name="Slide Image Placeholder 1"/>
-          <p:cNvSpPr>
-            <a:spLocks noGrp="1"/>
-          </p:cNvSpPr>
-          <p:nvPr>
-            <p:ph type="sldImg" idx="2"/>
-          </p:nvPr>
-        </p:nvSpPr>
-        <p:spPr/>
-      </p:sp>
-      <p:sp>
-        <p:nvSpPr>
-          <p:cNvPr id="3" name="Notes Placeholder 2"/>
-          <p:cNvSpPr>
-            <a:spLocks noGrp="1"/>
-          </p:cNvSpPr>
-          <p:nvPr>
-            <p:ph type="body" idx="3" sz="quarter"/>
-          </p:nvPr>
-        </p:nvSpPr>
-        <p:spPr/>
-        <p:txBody>
-          <a:bodyPr/>
-          <a:lstStyle/>
-          <a:p>
-            <a:r>
-              <a:t>Siehe Trainerhandbuch (Sektion 3) für Moderationshinweise, Timing und erwartete Teilnehmerreaktionen.</a:t>
+              <a:t>Selbstcheck nach 4 Wochen als Transferanker.</a:t>
             </a:r>
           </a:p>
         </p:txBody>
@@ -4707,7 +4630,7 @@
                 </a:solidFill>
                 <a:latin typeface="Consolas"/>
               </a:rPr>
-              <a:t>M11  ·  INHALT</a:t>
+              <a:t>M11  ·  ARBEITSBLATT</a:t>
             </a:r>
           </a:p>
         </p:txBody>
@@ -4828,7 +4751,7 @@
                 </a:solidFill>
                 <a:latin typeface="Arial"/>
               </a:rPr>
-              <a:t>Übung im Plenum: „Was höre ich wirklich?"</a:t>
+              <a:t>Das Zinsgespräch, das keines ist – bearbeiten</a:t>
             </a:r>
           </a:p>
         </p:txBody>
@@ -4841,8 +4764,8 @@
         </p:nvSpPr>
         <p:spPr>
           <a:xfrm>
-            <a:off x="685800" y="1417320"/>
-            <a:ext cx="10817352" cy="4892040"/>
+            <a:off x="685800" y="1554480"/>
+            <a:ext cx="10817352" cy="3840480"/>
           </a:xfrm>
           <a:prstGeom prst="rect">
             <a:avLst/>
@@ -4864,13 +4787,13 @@
               </a:spcAft>
             </a:pPr>
             <a:r>
-              <a:rPr sz="1300">
+              <a:rPr sz="1400">
                 <a:solidFill>
                   <a:srgbClr val="3D5466"/>
                 </a:solidFill>
                 <a:latin typeface="Arial"/>
               </a:rPr>
-              <a:t>▸  Der Trainer liest fünf Kundenaussagen vor. Die Teilnehmenden notieren: (1) Sachinhalt, (2) vermuteter latenter Hintergrund. Anschließend Auswertung im Plenum.</a:t>
+              <a:t>▸  Bereiten Sie SPIN-Fragen für den Fall vor (AB-1).</a:t>
             </a:r>
           </a:p>
           <a:p>
@@ -4883,13 +4806,13 @@
               </a:spcAft>
             </a:pPr>
             <a:r>
-              <a:rPr sz="1300">
+              <a:rPr sz="1400">
                 <a:solidFill>
                   <a:srgbClr val="3D5466"/>
                 </a:solidFill>
                 <a:latin typeface="Arial"/>
               </a:rPr>
-              <a:t>▸  ## 4.4 Aktives Zuhören als Schlüsselkompetenz</a:t>
+              <a:t>▸  Decken Sie im Rollenspiel den latenten Bedarf hinter der Zinsfrage auf.</a:t>
             </a:r>
           </a:p>
           <a:p>
@@ -4902,191 +4825,98 @@
               </a:spcAft>
             </a:pPr>
             <a:r>
-              <a:rPr sz="1300">
+              <a:rPr sz="1400">
                 <a:solidFill>
                   <a:srgbClr val="3D5466"/>
                 </a:solidFill>
                 <a:latin typeface="Arial"/>
               </a:rPr>
-              <a:t>▸  Techniken des aktiven Zuhörens:</a:t>
-            </a:r>
-          </a:p>
-          <a:p>
-            <a:pPr marL="190500" indent="-190500">
-              <a:spcBef>
-                <a:spcPts val="400"/>
-              </a:spcBef>
-              <a:spcAft>
-                <a:spcPts val="200"/>
-              </a:spcAft>
-            </a:pPr>
-            <a:r>
-              <a:rPr sz="1300">
-                <a:solidFill>
-                  <a:srgbClr val="3D5466"/>
+              <a:t>▸  Nutzen Sie den Beobachtungsbogen für strukturiertes Feedback (AB-2).</a:t>
+            </a:r>
+          </a:p>
+        </p:txBody>
+      </p:sp>
+      <p:sp>
+        <p:nvSpPr>
+          <p:cNvPr id="9" name="Rectangle 8"/>
+          <p:cNvSpPr/>
+          <p:nvPr/>
+        </p:nvSpPr>
+        <p:spPr>
+          <a:xfrm>
+            <a:off x="685800" y="5486400"/>
+            <a:ext cx="10817352" cy="640080"/>
+          </a:xfrm>
+          <a:prstGeom prst="rect">
+            <a:avLst/>
+          </a:prstGeom>
+          <a:solidFill>
+            <a:srgbClr val="1F2C56"/>
+          </a:solidFill>
+          <a:ln>
+            <a:noFill/>
+          </a:ln>
+        </p:spPr>
+        <p:style>
+          <a:lnRef idx="1">
+            <a:schemeClr val="accent1"/>
+          </a:lnRef>
+          <a:fillRef idx="3">
+            <a:schemeClr val="accent1"/>
+          </a:fillRef>
+          <a:effectRef idx="2">
+            <a:schemeClr val="accent1"/>
+          </a:effectRef>
+          <a:fontRef idx="minor">
+            <a:schemeClr val="lt1"/>
+          </a:fontRef>
+        </p:style>
+        <p:txBody>
+          <a:bodyPr rtlCol="0" anchor="ctr"/>
+          <a:lstStyle/>
+          <a:p>
+            <a:pPr algn="ctr"/>
+          </a:p>
+        </p:txBody>
+      </p:sp>
+      <p:sp>
+        <p:nvSpPr>
+          <p:cNvPr id="10" name="TextBox 9"/>
+          <p:cNvSpPr txBox="1"/>
+          <p:nvPr/>
+        </p:nvSpPr>
+        <p:spPr>
+          <a:xfrm>
+            <a:off x="868680" y="5596128"/>
+            <a:ext cx="10451592" cy="457200"/>
+          </a:xfrm>
+          <a:prstGeom prst="rect">
+            <a:avLst/>
+          </a:prstGeom>
+          <a:noFill/>
+        </p:spPr>
+        <p:txBody>
+          <a:bodyPr wrap="square">
+            <a:spAutoFit/>
+          </a:bodyPr>
+          <a:lstStyle/>
+          <a:p>
+            <a:pPr algn="l"/>
+            <a:r>
+              <a:rPr sz="1300" b="1" i="0">
+                <a:solidFill>
+                  <a:srgbClr val="FFFFFF"/>
                 </a:solidFill>
                 <a:latin typeface="Arial"/>
               </a:rPr>
-              <a:t>▸  Paraphrasieren: Den Kern des Gesagten in eigenen Worten wiedergeben. „Wenn ich Sie richtig verstehe, macht Ihnen weniger die Finanzierung Sorgen als die Frage, wer das Unternehmen in zehn Jahren führt?"</a:t>
-            </a:r>
-          </a:p>
-          <a:p>
-            <a:pPr marL="190500" indent="-190500">
-              <a:spcBef>
-                <a:spcPts val="400"/>
-              </a:spcBef>
-              <a:spcAft>
-                <a:spcPts val="200"/>
-              </a:spcAft>
-            </a:pPr>
-            <a:r>
-              <a:rPr sz="1300">
-                <a:solidFill>
-                  <a:srgbClr val="3D5466"/>
-                </a:solidFill>
-                <a:latin typeface="Arial"/>
-              </a:rPr>
-              <a:t>▸  Verbalisieren: Wahrgenommenes Gefühl benennen (mit Vorsicht). „Ich habe das Gefühl, das Thema liegt Ihnen schon länger am Herzen."</a:t>
-            </a:r>
-          </a:p>
-          <a:p>
-            <a:pPr marL="190500" indent="-190500">
-              <a:spcBef>
-                <a:spcPts val="400"/>
-              </a:spcBef>
-              <a:spcAft>
-                <a:spcPts val="200"/>
-              </a:spcAft>
-            </a:pPr>
-            <a:r>
-              <a:rPr sz="1300">
-                <a:solidFill>
-                  <a:srgbClr val="3D5466"/>
-                </a:solidFill>
-                <a:latin typeface="Arial"/>
-              </a:rPr>
-              <a:t>▸  Schweigen lassen: Pausen aushalten. Viele latente Bedarfe werden erst geäußert, wenn der Berater aufhört zu reden. Vier Sekunden Stille fühlen sich für einen unerfahrenen Berater wie eine Ewigkeit an – für den Kunden sind es vier Sekunden Denkzeit. Wer das Schweigen bricht, beraubt den Kunden dieser Denkzeit. Konkrete Hilfe: Nicken und Augenkontakt halten. Oder leise sagen: „Ich lasse Ihnen einen Moment." Nichts weiter. Rollenspielübung: Üben Sie bewusst, bis zu 6 Sekunden Stille auszuhalten, bevor Sie weitermachen – lassen Sie den Beobachter die Sekunden zählen.</a:t>
-            </a:r>
-          </a:p>
-          <a:p>
-            <a:pPr marL="190500" indent="-190500">
-              <a:spcBef>
-                <a:spcPts val="400"/>
-              </a:spcBef>
-              <a:spcAft>
-                <a:spcPts val="200"/>
-              </a:spcAft>
-            </a:pPr>
-            <a:r>
-              <a:rPr sz="1300">
-                <a:solidFill>
-                  <a:srgbClr val="3D5466"/>
-                </a:solidFill>
-                <a:latin typeface="Arial"/>
-              </a:rPr>
-              <a:t>▸  Offene Einladung: „Gibt es etwas, das wir heute noch ansprechen sollten, das wir noch nicht berührt haben?"</a:t>
-            </a:r>
-          </a:p>
-          <a:p>
-            <a:pPr marL="177800" indent="-177800">
-              <a:spcBef>
-                <a:spcPts val="600"/>
-              </a:spcBef>
-              <a:spcAft>
-                <a:spcPts val="200"/>
-              </a:spcAft>
-            </a:pPr>
-            <a:r>
-              <a:rPr sz="1200" i="1">
-                <a:solidFill>
-                  <a:srgbClr val="3D5466"/>
-                </a:solidFill>
-                <a:latin typeface="Arial"/>
-              </a:rPr>
-              <a:t>→  Eine der wichtigsten Fragen am Ende jedes Gesprächs: „Ist noch etwas, das ich wissen sollte?" Einfach. Direkt. Wirkungsvoll.</a:t>
-            </a:r>
-          </a:p>
-          <a:p>
-            <a:pPr marL="190500" indent="-190500">
-              <a:spcBef>
-                <a:spcPts val="400"/>
-              </a:spcBef>
-              <a:spcAft>
-                <a:spcPts val="200"/>
-              </a:spcAft>
-            </a:pPr>
-            <a:r>
-              <a:rPr sz="1300">
-                <a:solidFill>
-                  <a:srgbClr val="3D5466"/>
-                </a:solidFill>
-                <a:latin typeface="Arial"/>
-              </a:rPr>
-              <a:t>▸  ## 4.5 Praxiscase: Das Zinsgespräch, das keines ist</a:t>
-            </a:r>
-          </a:p>
-          <a:p>
-            <a:pPr marL="190500" indent="-190500">
-              <a:spcBef>
-                <a:spcPts val="400"/>
-              </a:spcBef>
-              <a:spcAft>
-                <a:spcPts val="200"/>
-              </a:spcAft>
-            </a:pPr>
-            <a:r>
-              <a:rPr sz="1300">
-                <a:solidFill>
-                  <a:srgbClr val="3D5466"/>
-                </a:solidFill>
-                <a:latin typeface="Arial"/>
-              </a:rPr>
-              <a:t>▸  Ausgangssituation</a:t>
-            </a:r>
-          </a:p>
-          <a:p>
-            <a:pPr marL="190500" indent="-190500">
-              <a:spcBef>
-                <a:spcPts val="400"/>
-              </a:spcBef>
-              <a:spcAft>
-                <a:spcPts val="200"/>
-              </a:spcAft>
-            </a:pPr>
-            <a:r>
-              <a:rPr sz="1300">
-                <a:solidFill>
-                  <a:srgbClr val="3D5466"/>
-                </a:solidFill>
-                <a:latin typeface="Arial"/>
-              </a:rPr>
-              <a:t>▸  Die zuständige Beraterin Lisa Kern bereitet sich auf ein Konditionengespräch vor.</a:t>
-            </a:r>
-          </a:p>
-          <a:p>
-            <a:pPr marL="190500" indent="-190500">
-              <a:spcBef>
-                <a:spcPts val="400"/>
-              </a:spcBef>
-              <a:spcAft>
-                <a:spcPts val="200"/>
-              </a:spcAft>
-            </a:pPr>
-            <a:r>
-              <a:rPr sz="1300">
-                <a:solidFill>
-                  <a:srgbClr val="3D5466"/>
-                </a:solidFill>
-                <a:latin typeface="Arial"/>
-              </a:rPr>
-              <a:t>▸  Das Gespräch</a:t>
-            </a:r>
-          </a:p>
-        </p:txBody>
-      </p:sp>
-      <p:sp>
-        <p:nvSpPr>
-          <p:cNvPr id="9" name="Rectangle 8"/>
+              <a:t>→  Bearbeitung im Teilnehmer-Workbook (Arbeitsblatt mit Ausfüllfeldern)</a:t>
+            </a:r>
+          </a:p>
+        </p:txBody>
+      </p:sp>
+      <p:sp>
+        <p:nvSpPr>
+          <p:cNvPr id="11" name="Rectangle 10"/>
           <p:cNvSpPr/>
           <p:nvPr/>
         </p:nvSpPr>
@@ -5129,7 +4959,7 @@
       </p:sp>
       <p:sp>
         <p:nvSpPr>
-          <p:cNvPr id="10" name="TextBox 9"/>
+          <p:cNvPr id="12" name="TextBox 11"/>
           <p:cNvSpPr txBox="1"/>
           <p:nvPr/>
         </p:nvSpPr>
@@ -5417,7 +5247,7 @@
                 </a:solidFill>
                 <a:latin typeface="Arial"/>
               </a:rPr>
-              <a:t>AB-1: SPIN-Fragen vorbereiten</a:t>
+              <a:t>Prinzip dieses Moduls</a:t>
             </a:r>
           </a:p>
         </p:txBody>
@@ -5443,6 +5273,25 @@
             <a:spAutoFit/>
           </a:bodyPr>
           <a:lstStyle/>
+          <a:p>
+            <a:pPr marL="177800" indent="-177800">
+              <a:spcBef>
+                <a:spcPts val="600"/>
+              </a:spcBef>
+              <a:spcAft>
+                <a:spcPts val="200"/>
+              </a:spcAft>
+            </a:pPr>
+            <a:r>
+              <a:rPr sz="1200" i="1">
+                <a:solidFill>
+                  <a:srgbClr val="3D5466"/>
+                </a:solidFill>
+                <a:latin typeface="Arial"/>
+              </a:rPr>
+              <a:t>→  Der wichtigste Bedarf ist der, den der Kunde noch nicht ausgesprochen hat.</a:t>
+            </a:r>
+          </a:p>
           <a:p>
             <a:pPr marL="190500" indent="-190500">
               <a:spcBef>
@@ -5459,26 +5308,7 @@
                 </a:solidFill>
                 <a:latin typeface="Arial"/>
               </a:rPr>
-              <a:t>▸  Bereiten Sie für jede SPIN-Kategorie mindestens zwei Fragen vor, die zu diesem Kunden passen:</a:t>
-            </a:r>
-          </a:p>
-          <a:p>
-            <a:pPr marL="190500" indent="-190500">
-              <a:spcBef>
-                <a:spcPts val="400"/>
-              </a:spcBef>
-              <a:spcAft>
-                <a:spcPts val="200"/>
-              </a:spcAft>
-            </a:pPr>
-            <a:r>
-              <a:rPr sz="1300">
-                <a:solidFill>
-                  <a:srgbClr val="3D5466"/>
-                </a:solidFill>
-                <a:latin typeface="Arial"/>
-              </a:rPr>
-              <a:t>▸  Meine Hypothese: Welchen latenten Bedarf könnte dieser Kunde haben?</a:t>
+              <a:t>▸  Explizite Wünsche bearbeitet jeder; latente Bedarfe mit SPIN-Fragen zu heben, unterscheidet den Berater vom Sachbearbeiter.</a:t>
             </a:r>
           </a:p>
         </p:txBody>
@@ -5594,7 +5424,7 @@
             <a:avLst/>
           </a:prstGeom>
           <a:solidFill>
-            <a:srgbClr val="FFFFFF"/>
+            <a:srgbClr val="EDEDF3"/>
           </a:solidFill>
           <a:ln>
             <a:noFill/>
@@ -5695,43 +5525,51 @@
                 </a:solidFill>
                 <a:latin typeface="Consolas"/>
               </a:rPr>
-              <a:t>M11  ·  ÜBERSICHT</a:t>
-            </a:r>
-          </a:p>
-        </p:txBody>
-      </p:sp>
-      <p:sp>
-        <p:nvSpPr>
-          <p:cNvPr id="5" name="TextBox 4"/>
-          <p:cNvSpPr txBox="1"/>
-          <p:nvPr/>
-        </p:nvSpPr>
-        <p:spPr>
-          <a:xfrm>
-            <a:off x="685800" y="502920"/>
-            <a:ext cx="10817352" cy="594360"/>
-          </a:xfrm>
-          <a:prstGeom prst="rect">
-            <a:avLst/>
-          </a:prstGeom>
-          <a:noFill/>
-        </p:spPr>
-        <p:txBody>
-          <a:bodyPr wrap="square">
-            <a:spAutoFit/>
-          </a:bodyPr>
-          <a:lstStyle/>
-          <a:p>
-            <a:pPr algn="l"/>
-            <a:r>
-              <a:rPr sz="2000" b="1" i="0">
-                <a:solidFill>
-                  <a:srgbClr val="1F2C56"/>
-                </a:solidFill>
-                <a:latin typeface="Arial"/>
-              </a:rPr>
-              <a:t>AB-1: SPIN-Fragen vorbereiten</a:t>
-            </a:r>
+              <a:t>M11  ·  INHALT</a:t>
+            </a:r>
+          </a:p>
+        </p:txBody>
+      </p:sp>
+      <p:sp>
+        <p:nvSpPr>
+          <p:cNvPr id="5" name="Rectangle 4"/>
+          <p:cNvSpPr/>
+          <p:nvPr/>
+        </p:nvSpPr>
+        <p:spPr>
+          <a:xfrm>
+            <a:off x="0" y="1234440"/>
+            <a:ext cx="12188952" cy="12700"/>
+          </a:xfrm>
+          <a:prstGeom prst="rect">
+            <a:avLst/>
+          </a:prstGeom>
+          <a:solidFill>
+            <a:srgbClr val="D8DFE4"/>
+          </a:solidFill>
+          <a:ln>
+            <a:noFill/>
+          </a:ln>
+        </p:spPr>
+        <p:style>
+          <a:lnRef idx="1">
+            <a:schemeClr val="accent1"/>
+          </a:lnRef>
+          <a:fillRef idx="3">
+            <a:schemeClr val="accent1"/>
+          </a:fillRef>
+          <a:effectRef idx="2">
+            <a:schemeClr val="accent1"/>
+          </a:effectRef>
+          <a:fontRef idx="minor">
+            <a:schemeClr val="lt1"/>
+          </a:fontRef>
+        </p:style>
+        <p:txBody>
+          <a:bodyPr rtlCol="0" anchor="ctr"/>
+          <a:lstStyle/>
+          <a:p>
+            <a:pPr algn="ctr"/>
           </a:p>
         </p:txBody>
       </p:sp>
@@ -5743,8 +5581,8 @@
         </p:nvSpPr>
         <p:spPr>
           <a:xfrm>
-            <a:off x="685800" y="1143000"/>
-            <a:ext cx="10817352" cy="25400"/>
+            <a:off x="685800" y="502920"/>
+            <a:ext cx="36576" cy="658368"/>
           </a:xfrm>
           <a:prstGeom prst="rect">
             <a:avLst/>
@@ -5778,583 +5616,6 @@
           </a:p>
         </p:txBody>
       </p:sp>
-      <p:graphicFrame>
-        <p:nvGraphicFramePr>
-          <p:cNvPr id="7" name="Table 6"/>
-          <p:cNvGraphicFramePr>
-            <a:graphicFrameLocks noGrp="1"/>
-          </p:cNvGraphicFramePr>
-          <p:nvPr/>
-        </p:nvGraphicFramePr>
-        <p:xfrm>
-          <a:off x="685800" y="1417320"/>
-          <a:ext cx="10817352" cy="1920240"/>
-        </p:xfrm>
-        <a:graphic>
-          <a:graphicData uri="http://schemas.openxmlformats.org/drawingml/2006/table">
-            <a:tbl>
-              <a:tblPr firstRow="1" bandRow="1">
-                <a:tableStyleId>{5C22544A-7EE6-4342-B048-85BDC9FD1C3A}</a:tableStyleId>
-              </a:tblPr>
-              <a:tblGrid>
-                <a:gridCol w="3605784"/>
-                <a:gridCol w="3605784"/>
-                <a:gridCol w="3605784"/>
-              </a:tblGrid>
-              <a:tr h="384048">
-                <a:tc>
-                  <a:txBody>
-                    <a:bodyPr/>
-                    <a:lstStyle/>
-                    <a:p>
-                      <a:r>
-                        <a:rPr sz="1100" b="1">
-                          <a:solidFill>
-                            <a:srgbClr val="FFFFFF"/>
-                          </a:solidFill>
-                          <a:latin typeface="Arial"/>
-                        </a:rPr>
-                        <a:t>Fragetyp</a:t>
-                      </a:r>
-                    </a:p>
-                  </a:txBody>
-                  <a:tcPr>
-                    <a:solidFill>
-                      <a:srgbClr val="1F2C56"/>
-                    </a:solidFill>
-                  </a:tcPr>
-                </a:tc>
-                <a:tc>
-                  <a:txBody>
-                    <a:bodyPr/>
-                    <a:lstStyle/>
-                    <a:p>
-                      <a:r>
-                        <a:rPr sz="1100" b="1">
-                          <a:solidFill>
-                            <a:srgbClr val="FFFFFF"/>
-                          </a:solidFill>
-                          <a:latin typeface="Arial"/>
-                        </a:rPr>
-                        <a:t>Meine Frage 1</a:t>
-                      </a:r>
-                    </a:p>
-                  </a:txBody>
-                  <a:tcPr>
-                    <a:solidFill>
-                      <a:srgbClr val="1F2C56"/>
-                    </a:solidFill>
-                  </a:tcPr>
-                </a:tc>
-                <a:tc>
-                  <a:txBody>
-                    <a:bodyPr/>
-                    <a:lstStyle/>
-                    <a:p>
-                      <a:r>
-                        <a:rPr sz="1100" b="1">
-                          <a:solidFill>
-                            <a:srgbClr val="FFFFFF"/>
-                          </a:solidFill>
-                          <a:latin typeface="Arial"/>
-                        </a:rPr>
-                        <a:t>Meine Frage 2</a:t>
-                      </a:r>
-                    </a:p>
-                  </a:txBody>
-                  <a:tcPr>
-                    <a:solidFill>
-                      <a:srgbClr val="1F2C56"/>
-                    </a:solidFill>
-                  </a:tcPr>
-                </a:tc>
-              </a:tr>
-              <a:tr h="384048">
-                <a:tc>
-                  <a:txBody>
-                    <a:bodyPr/>
-                    <a:lstStyle/>
-                    <a:p>
-                      <a:r>
-                        <a:rPr sz="1050">
-                          <a:solidFill>
-                            <a:srgbClr val="3D5466"/>
-                          </a:solidFill>
-                          <a:latin typeface="Arial"/>
-                        </a:rPr>
-                        <a:t>Situationsfrage</a:t>
-                      </a:r>
-                    </a:p>
-                  </a:txBody>
-                  <a:tcPr/>
-                </a:tc>
-                <a:tc>
-                  <a:txBody>
-                    <a:bodyPr/>
-                    <a:lstStyle/>
-                    <a:p/>
-                  </a:txBody>
-                  <a:tcPr/>
-                </a:tc>
-                <a:tc>
-                  <a:txBody>
-                    <a:bodyPr/>
-                    <a:lstStyle/>
-                    <a:p/>
-                  </a:txBody>
-                  <a:tcPr/>
-                </a:tc>
-              </a:tr>
-              <a:tr h="384048">
-                <a:tc>
-                  <a:txBody>
-                    <a:bodyPr/>
-                    <a:lstStyle/>
-                    <a:p>
-                      <a:r>
-                        <a:rPr sz="1050">
-                          <a:solidFill>
-                            <a:srgbClr val="3D5466"/>
-                          </a:solidFill>
-                          <a:latin typeface="Arial"/>
-                        </a:rPr>
-                        <a:t>Problemfrage</a:t>
-                      </a:r>
-                    </a:p>
-                  </a:txBody>
-                  <a:tcPr/>
-                </a:tc>
-                <a:tc>
-                  <a:txBody>
-                    <a:bodyPr/>
-                    <a:lstStyle/>
-                    <a:p/>
-                  </a:txBody>
-                  <a:tcPr/>
-                </a:tc>
-                <a:tc>
-                  <a:txBody>
-                    <a:bodyPr/>
-                    <a:lstStyle/>
-                    <a:p/>
-                  </a:txBody>
-                  <a:tcPr/>
-                </a:tc>
-              </a:tr>
-              <a:tr h="384048">
-                <a:tc>
-                  <a:txBody>
-                    <a:bodyPr/>
-                    <a:lstStyle/>
-                    <a:p>
-                      <a:r>
-                        <a:rPr sz="1050">
-                          <a:solidFill>
-                            <a:srgbClr val="3D5466"/>
-                          </a:solidFill>
-                          <a:latin typeface="Arial"/>
-                        </a:rPr>
-                        <a:t>Implikationsfrage</a:t>
-                      </a:r>
-                    </a:p>
-                  </a:txBody>
-                  <a:tcPr/>
-                </a:tc>
-                <a:tc>
-                  <a:txBody>
-                    <a:bodyPr/>
-                    <a:lstStyle/>
-                    <a:p/>
-                  </a:txBody>
-                  <a:tcPr/>
-                </a:tc>
-                <a:tc>
-                  <a:txBody>
-                    <a:bodyPr/>
-                    <a:lstStyle/>
-                    <a:p/>
-                  </a:txBody>
-                  <a:tcPr/>
-                </a:tc>
-              </a:tr>
-              <a:tr h="384048">
-                <a:tc>
-                  <a:txBody>
-                    <a:bodyPr/>
-                    <a:lstStyle/>
-                    <a:p>
-                      <a:r>
-                        <a:rPr sz="1050">
-                          <a:solidFill>
-                            <a:srgbClr val="3D5466"/>
-                          </a:solidFill>
-                          <a:latin typeface="Arial"/>
-                        </a:rPr>
-                        <a:t>Nutzenfrage</a:t>
-                      </a:r>
-                    </a:p>
-                  </a:txBody>
-                  <a:tcPr/>
-                </a:tc>
-                <a:tc>
-                  <a:txBody>
-                    <a:bodyPr/>
-                    <a:lstStyle/>
-                    <a:p/>
-                  </a:txBody>
-                  <a:tcPr/>
-                </a:tc>
-                <a:tc>
-                  <a:txBody>
-                    <a:bodyPr/>
-                    <a:lstStyle/>
-                    <a:p/>
-                  </a:txBody>
-                  <a:tcPr/>
-                </a:tc>
-              </a:tr>
-            </a:tbl>
-          </a:graphicData>
-        </a:graphic>
-      </p:graphicFrame>
-      <p:sp>
-        <p:nvSpPr>
-          <p:cNvPr id="8" name="Rectangle 7"/>
-          <p:cNvSpPr/>
-          <p:nvPr/>
-        </p:nvSpPr>
-        <p:spPr>
-          <a:xfrm>
-            <a:off x="0" y="6510528"/>
-            <a:ext cx="12188952" cy="347472"/>
-          </a:xfrm>
-          <a:prstGeom prst="rect">
-            <a:avLst/>
-          </a:prstGeom>
-          <a:solidFill>
-            <a:srgbClr val="0A1937"/>
-          </a:solidFill>
-          <a:ln>
-            <a:noFill/>
-          </a:ln>
-        </p:spPr>
-        <p:style>
-          <a:lnRef idx="1">
-            <a:schemeClr val="accent1"/>
-          </a:lnRef>
-          <a:fillRef idx="3">
-            <a:schemeClr val="accent1"/>
-          </a:fillRef>
-          <a:effectRef idx="2">
-            <a:schemeClr val="accent1"/>
-          </a:effectRef>
-          <a:fontRef idx="minor">
-            <a:schemeClr val="lt1"/>
-          </a:fontRef>
-        </p:style>
-        <p:txBody>
-          <a:bodyPr rtlCol="0" anchor="ctr"/>
-          <a:lstStyle/>
-          <a:p>
-            <a:pPr algn="ctr"/>
-          </a:p>
-        </p:txBody>
-      </p:sp>
-      <p:sp>
-        <p:nvSpPr>
-          <p:cNvPr id="9" name="TextBox 8"/>
-          <p:cNvSpPr txBox="1"/>
-          <p:nvPr/>
-        </p:nvSpPr>
-        <p:spPr>
-          <a:xfrm>
-            <a:off x="685800" y="6583680"/>
-            <a:ext cx="6490411" cy="256032"/>
-          </a:xfrm>
-          <a:prstGeom prst="rect">
-            <a:avLst/>
-          </a:prstGeom>
-          <a:noFill/>
-        </p:spPr>
-        <p:txBody>
-          <a:bodyPr wrap="none">
-            <a:spAutoFit/>
-          </a:bodyPr>
-          <a:lstStyle/>
-          <a:p>
-            <a:pPr algn="l"/>
-            <a:r>
-              <a:rPr sz="700">
-                <a:solidFill>
-                  <a:srgbClr val="A0B4D2"/>
-                </a:solidFill>
-                <a:latin typeface="Consolas"/>
-              </a:rPr>
-              <a:t>FKB Campus  ·  M11</a:t>
-            </a:r>
-          </a:p>
-        </p:txBody>
-      </p:sp>
-      <p:sp>
-        <p:nvSpPr>
-          <p:cNvPr id="10" name="TextBox 9"/>
-          <p:cNvSpPr txBox="1"/>
-          <p:nvPr/>
-        </p:nvSpPr>
-        <p:spPr>
-          <a:xfrm>
-            <a:off x="7176211" y="6583680"/>
-            <a:ext cx="4326940" cy="256032"/>
-          </a:xfrm>
-          <a:prstGeom prst="rect">
-            <a:avLst/>
-          </a:prstGeom>
-          <a:noFill/>
-        </p:spPr>
-        <p:txBody>
-          <a:bodyPr wrap="none">
-            <a:spAutoFit/>
-          </a:bodyPr>
-          <a:lstStyle/>
-          <a:p>
-            <a:pPr algn="r"/>
-            <a:r>
-              <a:rPr sz="700">
-                <a:solidFill>
-                  <a:srgbClr val="A0B4D2"/>
-                </a:solidFill>
-                <a:latin typeface="Consolas"/>
-              </a:rPr>
-              <a:t>Übersicht</a:t>
-            </a:r>
-          </a:p>
-        </p:txBody>
-      </p:sp>
-    </p:spTree>
-  </p:cSld>
-  <p:clrMapOvr>
-    <a:masterClrMapping/>
-  </p:clrMapOvr>
-</p:sld>
-</file>
-
-<file path=ppt/slides/slide13.xml><?xml version="1.0" encoding="utf-8"?>
-<p:sld xmlns:a="http://schemas.openxmlformats.org/drawingml/2006/main" xmlns:p="http://schemas.openxmlformats.org/presentationml/2006/main" xmlns:r="http://schemas.openxmlformats.org/officeDocument/2006/relationships">
-  <p:cSld>
-    <p:spTree>
-      <p:nvGrpSpPr>
-        <p:cNvPr id="1" name=""/>
-        <p:cNvGrpSpPr/>
-        <p:nvPr/>
-      </p:nvGrpSpPr>
-      <p:grpSpPr/>
-      <p:sp>
-        <p:nvSpPr>
-          <p:cNvPr id="2" name="Rectangle 1"/>
-          <p:cNvSpPr/>
-          <p:nvPr/>
-        </p:nvSpPr>
-        <p:spPr>
-          <a:xfrm>
-            <a:off x="0" y="0"/>
-            <a:ext cx="12188952" cy="6858000"/>
-          </a:xfrm>
-          <a:prstGeom prst="rect">
-            <a:avLst/>
-          </a:prstGeom>
-          <a:solidFill>
-            <a:srgbClr val="EDEDF3"/>
-          </a:solidFill>
-          <a:ln>
-            <a:noFill/>
-          </a:ln>
-        </p:spPr>
-        <p:style>
-          <a:lnRef idx="1">
-            <a:schemeClr val="accent1"/>
-          </a:lnRef>
-          <a:fillRef idx="3">
-            <a:schemeClr val="accent1"/>
-          </a:fillRef>
-          <a:effectRef idx="2">
-            <a:schemeClr val="accent1"/>
-          </a:effectRef>
-          <a:fontRef idx="minor">
-            <a:schemeClr val="lt1"/>
-          </a:fontRef>
-        </p:style>
-        <p:txBody>
-          <a:bodyPr rtlCol="0" anchor="ctr"/>
-          <a:lstStyle/>
-          <a:p>
-            <a:pPr algn="ctr"/>
-          </a:p>
-        </p:txBody>
-      </p:sp>
-      <p:sp>
-        <p:nvSpPr>
-          <p:cNvPr id="3" name="Rectangle 2"/>
-          <p:cNvSpPr/>
-          <p:nvPr/>
-        </p:nvSpPr>
-        <p:spPr>
-          <a:xfrm>
-            <a:off x="0" y="0"/>
-            <a:ext cx="12188952" cy="50292"/>
-          </a:xfrm>
-          <a:prstGeom prst="rect">
-            <a:avLst/>
-          </a:prstGeom>
-          <a:solidFill>
-            <a:srgbClr val="1F2C56"/>
-          </a:solidFill>
-          <a:ln>
-            <a:noFill/>
-          </a:ln>
-        </p:spPr>
-        <p:style>
-          <a:lnRef idx="1">
-            <a:schemeClr val="accent1"/>
-          </a:lnRef>
-          <a:fillRef idx="3">
-            <a:schemeClr val="accent1"/>
-          </a:fillRef>
-          <a:effectRef idx="2">
-            <a:schemeClr val="accent1"/>
-          </a:effectRef>
-          <a:fontRef idx="minor">
-            <a:schemeClr val="lt1"/>
-          </a:fontRef>
-        </p:style>
-        <p:txBody>
-          <a:bodyPr rtlCol="0" anchor="ctr"/>
-          <a:lstStyle/>
-          <a:p>
-            <a:pPr algn="ctr"/>
-          </a:p>
-        </p:txBody>
-      </p:sp>
-      <p:sp>
-        <p:nvSpPr>
-          <p:cNvPr id="4" name="TextBox 3"/>
-          <p:cNvSpPr txBox="1"/>
-          <p:nvPr/>
-        </p:nvSpPr>
-        <p:spPr>
-          <a:xfrm>
-            <a:off x="685800" y="109728"/>
-            <a:ext cx="10817352" cy="228600"/>
-          </a:xfrm>
-          <a:prstGeom prst="rect">
-            <a:avLst/>
-          </a:prstGeom>
-          <a:noFill/>
-        </p:spPr>
-        <p:txBody>
-          <a:bodyPr wrap="none">
-            <a:spAutoFit/>
-          </a:bodyPr>
-          <a:lstStyle/>
-          <a:p>
-            <a:pPr algn="l"/>
-            <a:r>
-              <a:rPr sz="750">
-                <a:solidFill>
-                  <a:srgbClr val="78808C"/>
-                </a:solidFill>
-                <a:latin typeface="Consolas"/>
-              </a:rPr>
-              <a:t>M11  ·  INHALT</a:t>
-            </a:r>
-          </a:p>
-        </p:txBody>
-      </p:sp>
-      <p:sp>
-        <p:nvSpPr>
-          <p:cNvPr id="5" name="Rectangle 4"/>
-          <p:cNvSpPr/>
-          <p:nvPr/>
-        </p:nvSpPr>
-        <p:spPr>
-          <a:xfrm>
-            <a:off x="0" y="1234440"/>
-            <a:ext cx="12188952" cy="12700"/>
-          </a:xfrm>
-          <a:prstGeom prst="rect">
-            <a:avLst/>
-          </a:prstGeom>
-          <a:solidFill>
-            <a:srgbClr val="D8DFE4"/>
-          </a:solidFill>
-          <a:ln>
-            <a:noFill/>
-          </a:ln>
-        </p:spPr>
-        <p:style>
-          <a:lnRef idx="1">
-            <a:schemeClr val="accent1"/>
-          </a:lnRef>
-          <a:fillRef idx="3">
-            <a:schemeClr val="accent1"/>
-          </a:fillRef>
-          <a:effectRef idx="2">
-            <a:schemeClr val="accent1"/>
-          </a:effectRef>
-          <a:fontRef idx="minor">
-            <a:schemeClr val="lt1"/>
-          </a:fontRef>
-        </p:style>
-        <p:txBody>
-          <a:bodyPr rtlCol="0" anchor="ctr"/>
-          <a:lstStyle/>
-          <a:p>
-            <a:pPr algn="ctr"/>
-          </a:p>
-        </p:txBody>
-      </p:sp>
-      <p:sp>
-        <p:nvSpPr>
-          <p:cNvPr id="6" name="Rectangle 5"/>
-          <p:cNvSpPr/>
-          <p:nvPr/>
-        </p:nvSpPr>
-        <p:spPr>
-          <a:xfrm>
-            <a:off x="685800" y="502920"/>
-            <a:ext cx="36576" cy="658368"/>
-          </a:xfrm>
-          <a:prstGeom prst="rect">
-            <a:avLst/>
-          </a:prstGeom>
-          <a:solidFill>
-            <a:srgbClr val="D9C089"/>
-          </a:solidFill>
-          <a:ln>
-            <a:noFill/>
-          </a:ln>
-        </p:spPr>
-        <p:style>
-          <a:lnRef idx="1">
-            <a:schemeClr val="accent1"/>
-          </a:lnRef>
-          <a:fillRef idx="3">
-            <a:schemeClr val="accent1"/>
-          </a:fillRef>
-          <a:effectRef idx="2">
-            <a:schemeClr val="accent1"/>
-          </a:effectRef>
-          <a:fontRef idx="minor">
-            <a:schemeClr val="lt1"/>
-          </a:fontRef>
-        </p:style>
-        <p:txBody>
-          <a:bodyPr rtlCol="0" anchor="ctr"/>
-          <a:lstStyle/>
-          <a:p>
-            <a:pPr algn="ctr"/>
-          </a:p>
-        </p:txBody>
-      </p:sp>
       <p:sp>
         <p:nvSpPr>
           <p:cNvPr id="7" name="TextBox 6"/>
@@ -6385,7 +5646,7 @@
                 </a:solidFill>
                 <a:latin typeface="Arial"/>
               </a:rPr>
-              <a:t>AB-2: Beobachtungsbogen Rollenspiel</a:t>
+              <a:t>Reflexion und Selbstcheck</a:t>
             </a:r>
           </a:p>
         </p:txBody>
@@ -6427,7 +5688,7 @@
                 </a:solidFill>
                 <a:latin typeface="Arial"/>
               </a:rPr>
-              <a:t>▸  (Wird vom Beobachter ausgefüllt – nicht vom Spielenden)</a:t>
+              <a:t>▸  Welche Kundenanfrage haben Sie zuletzt wörtlich genommen, statt nachzufragen?</a:t>
             </a:r>
           </a:p>
           <a:p>
@@ -6446,7 +5707,7 @@
                 </a:solidFill>
                 <a:latin typeface="Arial"/>
               </a:rPr>
-              <a:t>▸  Stärkster Moment im Gespräch:</a:t>
+              <a:t>▸  Auf welchem der vier Signalkanäle hören Sie am wenigsten genau hin?</a:t>
             </a:r>
           </a:p>
           <a:p>
@@ -6465,7 +5726,7 @@
                 </a:solidFill>
                 <a:latin typeface="Arial"/>
               </a:rPr>
-              <a:t>▸  Eine konkrete Verbesserungsmöglichkeit:</a:t>
+              <a:t>▸  Welche SPIN-Frage nehmen Sie in Ihr nächstes Gespräch mit?</a:t>
             </a:r>
           </a:p>
         </p:txBody>
@@ -6544,1121 +5805,6 @@
                 <a:latin typeface="Consolas"/>
               </a:rPr>
               <a:t>FKB Campus  ·  M11</a:t>
-            </a:r>
-          </a:p>
-        </p:txBody>
-      </p:sp>
-    </p:spTree>
-  </p:cSld>
-  <p:clrMapOvr>
-    <a:masterClrMapping/>
-  </p:clrMapOvr>
-</p:sld>
-</file>
-
-<file path=ppt/slides/slide14.xml><?xml version="1.0" encoding="utf-8"?>
-<p:sld xmlns:a="http://schemas.openxmlformats.org/drawingml/2006/main" xmlns:p="http://schemas.openxmlformats.org/presentationml/2006/main" xmlns:r="http://schemas.openxmlformats.org/officeDocument/2006/relationships">
-  <p:cSld>
-    <p:spTree>
-      <p:nvGrpSpPr>
-        <p:cNvPr id="1" name=""/>
-        <p:cNvGrpSpPr/>
-        <p:nvPr/>
-      </p:nvGrpSpPr>
-      <p:grpSpPr/>
-      <p:sp>
-        <p:nvSpPr>
-          <p:cNvPr id="2" name="Rectangle 1"/>
-          <p:cNvSpPr/>
-          <p:nvPr/>
-        </p:nvSpPr>
-        <p:spPr>
-          <a:xfrm>
-            <a:off x="0" y="0"/>
-            <a:ext cx="12188952" cy="6858000"/>
-          </a:xfrm>
-          <a:prstGeom prst="rect">
-            <a:avLst/>
-          </a:prstGeom>
-          <a:solidFill>
-            <a:srgbClr val="FFFFFF"/>
-          </a:solidFill>
-          <a:ln>
-            <a:noFill/>
-          </a:ln>
-        </p:spPr>
-        <p:style>
-          <a:lnRef idx="1">
-            <a:schemeClr val="accent1"/>
-          </a:lnRef>
-          <a:fillRef idx="3">
-            <a:schemeClr val="accent1"/>
-          </a:fillRef>
-          <a:effectRef idx="2">
-            <a:schemeClr val="accent1"/>
-          </a:effectRef>
-          <a:fontRef idx="minor">
-            <a:schemeClr val="lt1"/>
-          </a:fontRef>
-        </p:style>
-        <p:txBody>
-          <a:bodyPr rtlCol="0" anchor="ctr"/>
-          <a:lstStyle/>
-          <a:p>
-            <a:pPr algn="ctr"/>
-          </a:p>
-        </p:txBody>
-      </p:sp>
-      <p:sp>
-        <p:nvSpPr>
-          <p:cNvPr id="3" name="Rectangle 2"/>
-          <p:cNvSpPr/>
-          <p:nvPr/>
-        </p:nvSpPr>
-        <p:spPr>
-          <a:xfrm>
-            <a:off x="0" y="0"/>
-            <a:ext cx="12188952" cy="50292"/>
-          </a:xfrm>
-          <a:prstGeom prst="rect">
-            <a:avLst/>
-          </a:prstGeom>
-          <a:solidFill>
-            <a:srgbClr val="1F2C56"/>
-          </a:solidFill>
-          <a:ln>
-            <a:noFill/>
-          </a:ln>
-        </p:spPr>
-        <p:style>
-          <a:lnRef idx="1">
-            <a:schemeClr val="accent1"/>
-          </a:lnRef>
-          <a:fillRef idx="3">
-            <a:schemeClr val="accent1"/>
-          </a:fillRef>
-          <a:effectRef idx="2">
-            <a:schemeClr val="accent1"/>
-          </a:effectRef>
-          <a:fontRef idx="minor">
-            <a:schemeClr val="lt1"/>
-          </a:fontRef>
-        </p:style>
-        <p:txBody>
-          <a:bodyPr rtlCol="0" anchor="ctr"/>
-          <a:lstStyle/>
-          <a:p>
-            <a:pPr algn="ctr"/>
-          </a:p>
-        </p:txBody>
-      </p:sp>
-      <p:sp>
-        <p:nvSpPr>
-          <p:cNvPr id="4" name="TextBox 3"/>
-          <p:cNvSpPr txBox="1"/>
-          <p:nvPr/>
-        </p:nvSpPr>
-        <p:spPr>
-          <a:xfrm>
-            <a:off x="685800" y="109728"/>
-            <a:ext cx="10817352" cy="228600"/>
-          </a:xfrm>
-          <a:prstGeom prst="rect">
-            <a:avLst/>
-          </a:prstGeom>
-          <a:noFill/>
-        </p:spPr>
-        <p:txBody>
-          <a:bodyPr wrap="none">
-            <a:spAutoFit/>
-          </a:bodyPr>
-          <a:lstStyle/>
-          <a:p>
-            <a:pPr algn="l"/>
-            <a:r>
-              <a:rPr sz="750">
-                <a:solidFill>
-                  <a:srgbClr val="78808C"/>
-                </a:solidFill>
-                <a:latin typeface="Consolas"/>
-              </a:rPr>
-              <a:t>M11  ·  ÜBERSICHT</a:t>
-            </a:r>
-          </a:p>
-        </p:txBody>
-      </p:sp>
-      <p:sp>
-        <p:nvSpPr>
-          <p:cNvPr id="5" name="TextBox 4"/>
-          <p:cNvSpPr txBox="1"/>
-          <p:nvPr/>
-        </p:nvSpPr>
-        <p:spPr>
-          <a:xfrm>
-            <a:off x="685800" y="502920"/>
-            <a:ext cx="10817352" cy="594360"/>
-          </a:xfrm>
-          <a:prstGeom prst="rect">
-            <a:avLst/>
-          </a:prstGeom>
-          <a:noFill/>
-        </p:spPr>
-        <p:txBody>
-          <a:bodyPr wrap="square">
-            <a:spAutoFit/>
-          </a:bodyPr>
-          <a:lstStyle/>
-          <a:p>
-            <a:pPr algn="l"/>
-            <a:r>
-              <a:rPr sz="2000" b="1" i="0">
-                <a:solidFill>
-                  <a:srgbClr val="1F2C56"/>
-                </a:solidFill>
-                <a:latin typeface="Arial"/>
-              </a:rPr>
-              <a:t>AB-2: Beobachtungsbogen Rollenspiel</a:t>
-            </a:r>
-          </a:p>
-        </p:txBody>
-      </p:sp>
-      <p:sp>
-        <p:nvSpPr>
-          <p:cNvPr id="6" name="Rectangle 5"/>
-          <p:cNvSpPr/>
-          <p:nvPr/>
-        </p:nvSpPr>
-        <p:spPr>
-          <a:xfrm>
-            <a:off x="685800" y="1143000"/>
-            <a:ext cx="10817352" cy="25400"/>
-          </a:xfrm>
-          <a:prstGeom prst="rect">
-            <a:avLst/>
-          </a:prstGeom>
-          <a:solidFill>
-            <a:srgbClr val="D9C089"/>
-          </a:solidFill>
-          <a:ln>
-            <a:noFill/>
-          </a:ln>
-        </p:spPr>
-        <p:style>
-          <a:lnRef idx="1">
-            <a:schemeClr val="accent1"/>
-          </a:lnRef>
-          <a:fillRef idx="3">
-            <a:schemeClr val="accent1"/>
-          </a:fillRef>
-          <a:effectRef idx="2">
-            <a:schemeClr val="accent1"/>
-          </a:effectRef>
-          <a:fontRef idx="minor">
-            <a:schemeClr val="lt1"/>
-          </a:fontRef>
-        </p:style>
-        <p:txBody>
-          <a:bodyPr rtlCol="0" anchor="ctr"/>
-          <a:lstStyle/>
-          <a:p>
-            <a:pPr algn="ctr"/>
-          </a:p>
-        </p:txBody>
-      </p:sp>
-      <p:graphicFrame>
-        <p:nvGraphicFramePr>
-          <p:cNvPr id="7" name="Table 6"/>
-          <p:cNvGraphicFramePr>
-            <a:graphicFrameLocks noGrp="1"/>
-          </p:cNvGraphicFramePr>
-          <p:nvPr/>
-        </p:nvGraphicFramePr>
-        <p:xfrm>
-          <a:off x="685800" y="1417320"/>
-          <a:ext cx="10817352" cy="3072384"/>
-        </p:xfrm>
-        <a:graphic>
-          <a:graphicData uri="http://schemas.openxmlformats.org/drawingml/2006/table">
-            <a:tbl>
-              <a:tblPr firstRow="1" bandRow="1">
-                <a:tableStyleId>{5C22544A-7EE6-4342-B048-85BDC9FD1C3A}</a:tableStyleId>
-              </a:tblPr>
-              <a:tblGrid>
-                <a:gridCol w="2163470"/>
-                <a:gridCol w="2163470"/>
-                <a:gridCol w="2163470"/>
-                <a:gridCol w="2163470"/>
-                <a:gridCol w="2163472"/>
-              </a:tblGrid>
-              <a:tr h="384048">
-                <a:tc>
-                  <a:txBody>
-                    <a:bodyPr/>
-                    <a:lstStyle/>
-                    <a:p>
-                      <a:r>
-                        <a:rPr sz="1100" b="1">
-                          <a:solidFill>
-                            <a:srgbClr val="FFFFFF"/>
-                          </a:solidFill>
-                          <a:latin typeface="Arial"/>
-                        </a:rPr>
-                        <a:t>Beobachtungskriterium</a:t>
-                      </a:r>
-                    </a:p>
-                  </a:txBody>
-                  <a:tcPr>
-                    <a:solidFill>
-                      <a:srgbClr val="1F2C56"/>
-                    </a:solidFill>
-                  </a:tcPr>
-                </a:tc>
-                <a:tc>
-                  <a:txBody>
-                    <a:bodyPr/>
-                    <a:lstStyle/>
-                    <a:p>
-                      <a:r>
-                        <a:rPr sz="1100" b="1">
-                          <a:solidFill>
-                            <a:srgbClr val="FFFFFF"/>
-                          </a:solidFill>
-                          <a:latin typeface="Arial"/>
-                        </a:rPr>
-                        <a:t>Sehr gut (3)</a:t>
-                      </a:r>
-                    </a:p>
-                  </a:txBody>
-                  <a:tcPr>
-                    <a:solidFill>
-                      <a:srgbClr val="1F2C56"/>
-                    </a:solidFill>
-                  </a:tcPr>
-                </a:tc>
-                <a:tc>
-                  <a:txBody>
-                    <a:bodyPr/>
-                    <a:lstStyle/>
-                    <a:p>
-                      <a:r>
-                        <a:rPr sz="1100" b="1">
-                          <a:solidFill>
-                            <a:srgbClr val="FFFFFF"/>
-                          </a:solidFill>
-                          <a:latin typeface="Arial"/>
-                        </a:rPr>
-                        <a:t>Gut (2)</a:t>
-                      </a:r>
-                    </a:p>
-                  </a:txBody>
-                  <a:tcPr>
-                    <a:solidFill>
-                      <a:srgbClr val="1F2C56"/>
-                    </a:solidFill>
-                  </a:tcPr>
-                </a:tc>
-                <a:tc>
-                  <a:txBody>
-                    <a:bodyPr/>
-                    <a:lstStyle/>
-                    <a:p>
-                      <a:r>
-                        <a:rPr sz="1100" b="1">
-                          <a:solidFill>
-                            <a:srgbClr val="FFFFFF"/>
-                          </a:solidFill>
-                          <a:latin typeface="Arial"/>
-                        </a:rPr>
-                        <a:t>Ausbaufähig (1)</a:t>
-                      </a:r>
-                    </a:p>
-                  </a:txBody>
-                  <a:tcPr>
-                    <a:solidFill>
-                      <a:srgbClr val="1F2C56"/>
-                    </a:solidFill>
-                  </a:tcPr>
-                </a:tc>
-                <a:tc>
-                  <a:txBody>
-                    <a:bodyPr/>
-                    <a:lstStyle/>
-                    <a:p>
-                      <a:r>
-                        <a:rPr sz="1100" b="1">
-                          <a:solidFill>
-                            <a:srgbClr val="FFFFFF"/>
-                          </a:solidFill>
-                          <a:latin typeface="Arial"/>
-                        </a:rPr>
-                        <a:t>Nicht beobachtet</a:t>
-                      </a:r>
-                    </a:p>
-                  </a:txBody>
-                  <a:tcPr>
-                    <a:solidFill>
-                      <a:srgbClr val="1F2C56"/>
-                    </a:solidFill>
-                  </a:tcPr>
-                </a:tc>
-              </a:tr>
-              <a:tr h="384048">
-                <a:tc>
-                  <a:txBody>
-                    <a:bodyPr/>
-                    <a:lstStyle/>
-                    <a:p>
-                      <a:r>
-                        <a:rPr sz="1050">
-                          <a:solidFill>
-                            <a:srgbClr val="3D5466"/>
-                          </a:solidFill>
-                          <a:latin typeface="Arial"/>
-                        </a:rPr>
-                        <a:t>Offene Einstiegsfragen gestellt</a:t>
-                      </a:r>
-                    </a:p>
-                  </a:txBody>
-                  <a:tcPr/>
-                </a:tc>
-                <a:tc>
-                  <a:txBody>
-                    <a:bodyPr/>
-                    <a:lstStyle/>
-                    <a:p>
-                      <a:r>
-                        <a:rPr sz="1050">
-                          <a:solidFill>
-                            <a:srgbClr val="3D5466"/>
-                          </a:solidFill>
-                          <a:latin typeface="Arial"/>
-                        </a:rPr>
-                        <a:t>☐</a:t>
-                      </a:r>
-                    </a:p>
-                  </a:txBody>
-                  <a:tcPr/>
-                </a:tc>
-                <a:tc>
-                  <a:txBody>
-                    <a:bodyPr/>
-                    <a:lstStyle/>
-                    <a:p>
-                      <a:r>
-                        <a:rPr sz="1050">
-                          <a:solidFill>
-                            <a:srgbClr val="3D5466"/>
-                          </a:solidFill>
-                          <a:latin typeface="Arial"/>
-                        </a:rPr>
-                        <a:t>☐</a:t>
-                      </a:r>
-                    </a:p>
-                  </a:txBody>
-                  <a:tcPr/>
-                </a:tc>
-                <a:tc>
-                  <a:txBody>
-                    <a:bodyPr/>
-                    <a:lstStyle/>
-                    <a:p>
-                      <a:r>
-                        <a:rPr sz="1050">
-                          <a:solidFill>
-                            <a:srgbClr val="3D5466"/>
-                          </a:solidFill>
-                          <a:latin typeface="Arial"/>
-                        </a:rPr>
-                        <a:t>☐</a:t>
-                      </a:r>
-                    </a:p>
-                  </a:txBody>
-                  <a:tcPr/>
-                </a:tc>
-                <a:tc>
-                  <a:txBody>
-                    <a:bodyPr/>
-                    <a:lstStyle/>
-                    <a:p>
-                      <a:r>
-                        <a:rPr sz="1050">
-                          <a:solidFill>
-                            <a:srgbClr val="3D5466"/>
-                          </a:solidFill>
-                          <a:latin typeface="Arial"/>
-                        </a:rPr>
-                        <a:t>☐</a:t>
-                      </a:r>
-                    </a:p>
-                  </a:txBody>
-                  <a:tcPr/>
-                </a:tc>
-              </a:tr>
-              <a:tr h="384048">
-                <a:tc>
-                  <a:txBody>
-                    <a:bodyPr/>
-                    <a:lstStyle/>
-                    <a:p>
-                      <a:r>
-                        <a:rPr sz="1050">
-                          <a:solidFill>
-                            <a:srgbClr val="3D5466"/>
-                          </a:solidFill>
-                          <a:latin typeface="Arial"/>
-                        </a:rPr>
-                        <a:t>Problemfragen aktiv eingesetzt</a:t>
-                      </a:r>
-                    </a:p>
-                  </a:txBody>
-                  <a:tcPr/>
-                </a:tc>
-                <a:tc>
-                  <a:txBody>
-                    <a:bodyPr/>
-                    <a:lstStyle/>
-                    <a:p>
-                      <a:r>
-                        <a:rPr sz="1050">
-                          <a:solidFill>
-                            <a:srgbClr val="3D5466"/>
-                          </a:solidFill>
-                          <a:latin typeface="Arial"/>
-                        </a:rPr>
-                        <a:t>☐</a:t>
-                      </a:r>
-                    </a:p>
-                  </a:txBody>
-                  <a:tcPr/>
-                </a:tc>
-                <a:tc>
-                  <a:txBody>
-                    <a:bodyPr/>
-                    <a:lstStyle/>
-                    <a:p>
-                      <a:r>
-                        <a:rPr sz="1050">
-                          <a:solidFill>
-                            <a:srgbClr val="3D5466"/>
-                          </a:solidFill>
-                          <a:latin typeface="Arial"/>
-                        </a:rPr>
-                        <a:t>☐</a:t>
-                      </a:r>
-                    </a:p>
-                  </a:txBody>
-                  <a:tcPr/>
-                </a:tc>
-                <a:tc>
-                  <a:txBody>
-                    <a:bodyPr/>
-                    <a:lstStyle/>
-                    <a:p>
-                      <a:r>
-                        <a:rPr sz="1050">
-                          <a:solidFill>
-                            <a:srgbClr val="3D5466"/>
-                          </a:solidFill>
-                          <a:latin typeface="Arial"/>
-                        </a:rPr>
-                        <a:t>☐</a:t>
-                      </a:r>
-                    </a:p>
-                  </a:txBody>
-                  <a:tcPr/>
-                </a:tc>
-                <a:tc>
-                  <a:txBody>
-                    <a:bodyPr/>
-                    <a:lstStyle/>
-                    <a:p>
-                      <a:r>
-                        <a:rPr sz="1050">
-                          <a:solidFill>
-                            <a:srgbClr val="3D5466"/>
-                          </a:solidFill>
-                          <a:latin typeface="Arial"/>
-                        </a:rPr>
-                        <a:t>☐</a:t>
-                      </a:r>
-                    </a:p>
-                  </a:txBody>
-                  <a:tcPr/>
-                </a:tc>
-              </a:tr>
-              <a:tr h="384048">
-                <a:tc>
-                  <a:txBody>
-                    <a:bodyPr/>
-                    <a:lstStyle/>
-                    <a:p>
-                      <a:r>
-                        <a:rPr sz="1050">
-                          <a:solidFill>
-                            <a:srgbClr val="3D5466"/>
-                          </a:solidFill>
-                          <a:latin typeface="Arial"/>
-                        </a:rPr>
-                        <a:t>Implikationsfragen verwendet</a:t>
-                      </a:r>
-                    </a:p>
-                  </a:txBody>
-                  <a:tcPr/>
-                </a:tc>
-                <a:tc>
-                  <a:txBody>
-                    <a:bodyPr/>
-                    <a:lstStyle/>
-                    <a:p>
-                      <a:r>
-                        <a:rPr sz="1050">
-                          <a:solidFill>
-                            <a:srgbClr val="3D5466"/>
-                          </a:solidFill>
-                          <a:latin typeface="Arial"/>
-                        </a:rPr>
-                        <a:t>☐</a:t>
-                      </a:r>
-                    </a:p>
-                  </a:txBody>
-                  <a:tcPr/>
-                </a:tc>
-                <a:tc>
-                  <a:txBody>
-                    <a:bodyPr/>
-                    <a:lstStyle/>
-                    <a:p>
-                      <a:r>
-                        <a:rPr sz="1050">
-                          <a:solidFill>
-                            <a:srgbClr val="3D5466"/>
-                          </a:solidFill>
-                          <a:latin typeface="Arial"/>
-                        </a:rPr>
-                        <a:t>☐</a:t>
-                      </a:r>
-                    </a:p>
-                  </a:txBody>
-                  <a:tcPr/>
-                </a:tc>
-                <a:tc>
-                  <a:txBody>
-                    <a:bodyPr/>
-                    <a:lstStyle/>
-                    <a:p>
-                      <a:r>
-                        <a:rPr sz="1050">
-                          <a:solidFill>
-                            <a:srgbClr val="3D5466"/>
-                          </a:solidFill>
-                          <a:latin typeface="Arial"/>
-                        </a:rPr>
-                        <a:t>☐</a:t>
-                      </a:r>
-                    </a:p>
-                  </a:txBody>
-                  <a:tcPr/>
-                </a:tc>
-                <a:tc>
-                  <a:txBody>
-                    <a:bodyPr/>
-                    <a:lstStyle/>
-                    <a:p>
-                      <a:r>
-                        <a:rPr sz="1050">
-                          <a:solidFill>
-                            <a:srgbClr val="3D5466"/>
-                          </a:solidFill>
-                          <a:latin typeface="Arial"/>
-                        </a:rPr>
-                        <a:t>☐</a:t>
-                      </a:r>
-                    </a:p>
-                  </a:txBody>
-                  <a:tcPr/>
-                </a:tc>
-              </a:tr>
-              <a:tr h="384048">
-                <a:tc>
-                  <a:txBody>
-                    <a:bodyPr/>
-                    <a:lstStyle/>
-                    <a:p>
-                      <a:r>
-                        <a:rPr sz="1050">
-                          <a:solidFill>
-                            <a:srgbClr val="3D5466"/>
-                          </a:solidFill>
-                          <a:latin typeface="Arial"/>
-                        </a:rPr>
-                        <a:t>Latente Signale aufgegriffen</a:t>
-                      </a:r>
-                    </a:p>
-                  </a:txBody>
-                  <a:tcPr/>
-                </a:tc>
-                <a:tc>
-                  <a:txBody>
-                    <a:bodyPr/>
-                    <a:lstStyle/>
-                    <a:p>
-                      <a:r>
-                        <a:rPr sz="1050">
-                          <a:solidFill>
-                            <a:srgbClr val="3D5466"/>
-                          </a:solidFill>
-                          <a:latin typeface="Arial"/>
-                        </a:rPr>
-                        <a:t>☐</a:t>
-                      </a:r>
-                    </a:p>
-                  </a:txBody>
-                  <a:tcPr/>
-                </a:tc>
-                <a:tc>
-                  <a:txBody>
-                    <a:bodyPr/>
-                    <a:lstStyle/>
-                    <a:p>
-                      <a:r>
-                        <a:rPr sz="1050">
-                          <a:solidFill>
-                            <a:srgbClr val="3D5466"/>
-                          </a:solidFill>
-                          <a:latin typeface="Arial"/>
-                        </a:rPr>
-                        <a:t>☐</a:t>
-                      </a:r>
-                    </a:p>
-                  </a:txBody>
-                  <a:tcPr/>
-                </a:tc>
-                <a:tc>
-                  <a:txBody>
-                    <a:bodyPr/>
-                    <a:lstStyle/>
-                    <a:p>
-                      <a:r>
-                        <a:rPr sz="1050">
-                          <a:solidFill>
-                            <a:srgbClr val="3D5466"/>
-                          </a:solidFill>
-                          <a:latin typeface="Arial"/>
-                        </a:rPr>
-                        <a:t>☐</a:t>
-                      </a:r>
-                    </a:p>
-                  </a:txBody>
-                  <a:tcPr/>
-                </a:tc>
-                <a:tc>
-                  <a:txBody>
-                    <a:bodyPr/>
-                    <a:lstStyle/>
-                    <a:p>
-                      <a:r>
-                        <a:rPr sz="1050">
-                          <a:solidFill>
-                            <a:srgbClr val="3D5466"/>
-                          </a:solidFill>
-                          <a:latin typeface="Arial"/>
-                        </a:rPr>
-                        <a:t>☐</a:t>
-                      </a:r>
-                    </a:p>
-                  </a:txBody>
-                  <a:tcPr/>
-                </a:tc>
-              </a:tr>
-              <a:tr h="384048">
-                <a:tc>
-                  <a:txBody>
-                    <a:bodyPr/>
-                    <a:lstStyle/>
-                    <a:p>
-                      <a:r>
-                        <a:rPr sz="1050">
-                          <a:solidFill>
-                            <a:srgbClr val="3D5466"/>
-                          </a:solidFill>
-                          <a:latin typeface="Arial"/>
-                        </a:rPr>
-                        <a:t>Schweigen ausgehalten</a:t>
-                      </a:r>
-                    </a:p>
-                  </a:txBody>
-                  <a:tcPr/>
-                </a:tc>
-                <a:tc>
-                  <a:txBody>
-                    <a:bodyPr/>
-                    <a:lstStyle/>
-                    <a:p>
-                      <a:r>
-                        <a:rPr sz="1050">
-                          <a:solidFill>
-                            <a:srgbClr val="3D5466"/>
-                          </a:solidFill>
-                          <a:latin typeface="Arial"/>
-                        </a:rPr>
-                        <a:t>☐</a:t>
-                      </a:r>
-                    </a:p>
-                  </a:txBody>
-                  <a:tcPr/>
-                </a:tc>
-                <a:tc>
-                  <a:txBody>
-                    <a:bodyPr/>
-                    <a:lstStyle/>
-                    <a:p>
-                      <a:r>
-                        <a:rPr sz="1050">
-                          <a:solidFill>
-                            <a:srgbClr val="3D5466"/>
-                          </a:solidFill>
-                          <a:latin typeface="Arial"/>
-                        </a:rPr>
-                        <a:t>☐</a:t>
-                      </a:r>
-                    </a:p>
-                  </a:txBody>
-                  <a:tcPr/>
-                </a:tc>
-                <a:tc>
-                  <a:txBody>
-                    <a:bodyPr/>
-                    <a:lstStyle/>
-                    <a:p>
-                      <a:r>
-                        <a:rPr sz="1050">
-                          <a:solidFill>
-                            <a:srgbClr val="3D5466"/>
-                          </a:solidFill>
-                          <a:latin typeface="Arial"/>
-                        </a:rPr>
-                        <a:t>☐</a:t>
-                      </a:r>
-                    </a:p>
-                  </a:txBody>
-                  <a:tcPr/>
-                </a:tc>
-                <a:tc>
-                  <a:txBody>
-                    <a:bodyPr/>
-                    <a:lstStyle/>
-                    <a:p>
-                      <a:r>
-                        <a:rPr sz="1050">
-                          <a:solidFill>
-                            <a:srgbClr val="3D5466"/>
-                          </a:solidFill>
-                          <a:latin typeface="Arial"/>
-                        </a:rPr>
-                        <a:t>☐</a:t>
-                      </a:r>
-                    </a:p>
-                  </a:txBody>
-                  <a:tcPr/>
-                </a:tc>
-              </a:tr>
-              <a:tr h="384048">
-                <a:tc>
-                  <a:txBody>
-                    <a:bodyPr/>
-                    <a:lstStyle/>
-                    <a:p>
-                      <a:r>
-                        <a:rPr sz="1050">
-                          <a:solidFill>
-                            <a:srgbClr val="3D5466"/>
-                          </a:solidFill>
-                          <a:latin typeface="Arial"/>
-                        </a:rPr>
-                        <a:t>Paraphrase/Zusammenfassung eingesetzt</a:t>
-                      </a:r>
-                    </a:p>
-                  </a:txBody>
-                  <a:tcPr/>
-                </a:tc>
-                <a:tc>
-                  <a:txBody>
-                    <a:bodyPr/>
-                    <a:lstStyle/>
-                    <a:p>
-                      <a:r>
-                        <a:rPr sz="1050">
-                          <a:solidFill>
-                            <a:srgbClr val="3D5466"/>
-                          </a:solidFill>
-                          <a:latin typeface="Arial"/>
-                        </a:rPr>
-                        <a:t>☐</a:t>
-                      </a:r>
-                    </a:p>
-                  </a:txBody>
-                  <a:tcPr/>
-                </a:tc>
-                <a:tc>
-                  <a:txBody>
-                    <a:bodyPr/>
-                    <a:lstStyle/>
-                    <a:p>
-                      <a:r>
-                        <a:rPr sz="1050">
-                          <a:solidFill>
-                            <a:srgbClr val="3D5466"/>
-                          </a:solidFill>
-                          <a:latin typeface="Arial"/>
-                        </a:rPr>
-                        <a:t>☐</a:t>
-                      </a:r>
-                    </a:p>
-                  </a:txBody>
-                  <a:tcPr/>
-                </a:tc>
-                <a:tc>
-                  <a:txBody>
-                    <a:bodyPr/>
-                    <a:lstStyle/>
-                    <a:p>
-                      <a:r>
-                        <a:rPr sz="1050">
-                          <a:solidFill>
-                            <a:srgbClr val="3D5466"/>
-                          </a:solidFill>
-                          <a:latin typeface="Arial"/>
-                        </a:rPr>
-                        <a:t>☐</a:t>
-                      </a:r>
-                    </a:p>
-                  </a:txBody>
-                  <a:tcPr/>
-                </a:tc>
-                <a:tc>
-                  <a:txBody>
-                    <a:bodyPr/>
-                    <a:lstStyle/>
-                    <a:p>
-                      <a:r>
-                        <a:rPr sz="1050">
-                          <a:solidFill>
-                            <a:srgbClr val="3D5466"/>
-                          </a:solidFill>
-                          <a:latin typeface="Arial"/>
-                        </a:rPr>
-                        <a:t>☐</a:t>
-                      </a:r>
-                    </a:p>
-                  </a:txBody>
-                  <a:tcPr/>
-                </a:tc>
-              </a:tr>
-              <a:tr h="384048">
-                <a:tc>
-                  <a:txBody>
-                    <a:bodyPr/>
-                    <a:lstStyle/>
-                    <a:p>
-                      <a:r>
-                        <a:rPr sz="1050">
-                          <a:solidFill>
-                            <a:srgbClr val="3D5466"/>
-                          </a:solidFill>
-                          <a:latin typeface="Arial"/>
-                        </a:rPr>
-                        <a:t>Zu früh zu Produkten gewechselt (neg.)</a:t>
-                      </a:r>
-                    </a:p>
-                  </a:txBody>
-                  <a:tcPr/>
-                </a:tc>
-                <a:tc>
-                  <a:txBody>
-                    <a:bodyPr/>
-                    <a:lstStyle/>
-                    <a:p>
-                      <a:r>
-                        <a:rPr sz="1050">
-                          <a:solidFill>
-                            <a:srgbClr val="3D5466"/>
-                          </a:solidFill>
-                          <a:latin typeface="Arial"/>
-                        </a:rPr>
-                        <a:t>☐</a:t>
-                      </a:r>
-                    </a:p>
-                  </a:txBody>
-                  <a:tcPr/>
-                </a:tc>
-                <a:tc>
-                  <a:txBody>
-                    <a:bodyPr/>
-                    <a:lstStyle/>
-                    <a:p>
-                      <a:r>
-                        <a:rPr sz="1050">
-                          <a:solidFill>
-                            <a:srgbClr val="3D5466"/>
-                          </a:solidFill>
-                          <a:latin typeface="Arial"/>
-                        </a:rPr>
-                        <a:t>☐</a:t>
-                      </a:r>
-                    </a:p>
-                  </a:txBody>
-                  <a:tcPr/>
-                </a:tc>
-                <a:tc>
-                  <a:txBody>
-                    <a:bodyPr/>
-                    <a:lstStyle/>
-                    <a:p>
-                      <a:r>
-                        <a:rPr sz="1050">
-                          <a:solidFill>
-                            <a:srgbClr val="3D5466"/>
-                          </a:solidFill>
-                          <a:latin typeface="Arial"/>
-                        </a:rPr>
-                        <a:t>☐</a:t>
-                      </a:r>
-                    </a:p>
-                  </a:txBody>
-                  <a:tcPr/>
-                </a:tc>
-                <a:tc>
-                  <a:txBody>
-                    <a:bodyPr/>
-                    <a:lstStyle/>
-                    <a:p>
-                      <a:r>
-                        <a:rPr sz="1050">
-                          <a:solidFill>
-                            <a:srgbClr val="3D5466"/>
-                          </a:solidFill>
-                          <a:latin typeface="Arial"/>
-                        </a:rPr>
-                        <a:t>☐</a:t>
-                      </a:r>
-                    </a:p>
-                  </a:txBody>
-                  <a:tcPr/>
-                </a:tc>
-              </a:tr>
-            </a:tbl>
-          </a:graphicData>
-        </a:graphic>
-      </p:graphicFrame>
-      <p:sp>
-        <p:nvSpPr>
-          <p:cNvPr id="8" name="Rectangle 7"/>
-          <p:cNvSpPr/>
-          <p:nvPr/>
-        </p:nvSpPr>
-        <p:spPr>
-          <a:xfrm>
-            <a:off x="0" y="6510528"/>
-            <a:ext cx="12188952" cy="347472"/>
-          </a:xfrm>
-          <a:prstGeom prst="rect">
-            <a:avLst/>
-          </a:prstGeom>
-          <a:solidFill>
-            <a:srgbClr val="0A1937"/>
-          </a:solidFill>
-          <a:ln>
-            <a:noFill/>
-          </a:ln>
-        </p:spPr>
-        <p:style>
-          <a:lnRef idx="1">
-            <a:schemeClr val="accent1"/>
-          </a:lnRef>
-          <a:fillRef idx="3">
-            <a:schemeClr val="accent1"/>
-          </a:fillRef>
-          <a:effectRef idx="2">
-            <a:schemeClr val="accent1"/>
-          </a:effectRef>
-          <a:fontRef idx="minor">
-            <a:schemeClr val="lt1"/>
-          </a:fontRef>
-        </p:style>
-        <p:txBody>
-          <a:bodyPr rtlCol="0" anchor="ctr"/>
-          <a:lstStyle/>
-          <a:p>
-            <a:pPr algn="ctr"/>
-          </a:p>
-        </p:txBody>
-      </p:sp>
-      <p:sp>
-        <p:nvSpPr>
-          <p:cNvPr id="9" name="TextBox 8"/>
-          <p:cNvSpPr txBox="1"/>
-          <p:nvPr/>
-        </p:nvSpPr>
-        <p:spPr>
-          <a:xfrm>
-            <a:off x="685800" y="6583680"/>
-            <a:ext cx="6490411" cy="256032"/>
-          </a:xfrm>
-          <a:prstGeom prst="rect">
-            <a:avLst/>
-          </a:prstGeom>
-          <a:noFill/>
-        </p:spPr>
-        <p:txBody>
-          <a:bodyPr wrap="none">
-            <a:spAutoFit/>
-          </a:bodyPr>
-          <a:lstStyle/>
-          <a:p>
-            <a:pPr algn="l"/>
-            <a:r>
-              <a:rPr sz="700">
-                <a:solidFill>
-                  <a:srgbClr val="A0B4D2"/>
-                </a:solidFill>
-                <a:latin typeface="Consolas"/>
-              </a:rPr>
-              <a:t>FKB Campus  ·  M11</a:t>
-            </a:r>
-          </a:p>
-        </p:txBody>
-      </p:sp>
-      <p:sp>
-        <p:nvSpPr>
-          <p:cNvPr id="10" name="TextBox 9"/>
-          <p:cNvSpPr txBox="1"/>
-          <p:nvPr/>
-        </p:nvSpPr>
-        <p:spPr>
-          <a:xfrm>
-            <a:off x="7176211" y="6583680"/>
-            <a:ext cx="4326940" cy="256032"/>
-          </a:xfrm>
-          <a:prstGeom prst="rect">
-            <a:avLst/>
-          </a:prstGeom>
-          <a:noFill/>
-        </p:spPr>
-        <p:txBody>
-          <a:bodyPr wrap="none">
-            <a:spAutoFit/>
-          </a:bodyPr>
-          <a:lstStyle/>
-          <a:p>
-            <a:pPr algn="r"/>
-            <a:r>
-              <a:rPr sz="700">
-                <a:solidFill>
-                  <a:srgbClr val="A0B4D2"/>
-                </a:solidFill>
-                <a:latin typeface="Consolas"/>
-              </a:rPr>
-              <a:t>Übersicht</a:t>
             </a:r>
           </a:p>
         </p:txBody>
@@ -9274,7 +7420,7 @@
                 </a:solidFill>
                 <a:latin typeface="Arial"/>
               </a:rPr>
-              <a:t>Das Eisberg-Modell der Kundenbedürfnisse</a:t>
+              <a:t>Der wichtigste Bedarf ist der unausgesprochene</a:t>
             </a:r>
           </a:p>
         </p:txBody>
@@ -9300,6 +7446,25 @@
             <a:spAutoFit/>
           </a:bodyPr>
           <a:lstStyle/>
+          <a:p>
+            <a:pPr marL="177800" indent="-177800">
+              <a:spcBef>
+                <a:spcPts val="600"/>
+              </a:spcBef>
+              <a:spcAft>
+                <a:spcPts val="200"/>
+              </a:spcAft>
+            </a:pPr>
+            <a:r>
+              <a:rPr sz="1200" i="1">
+                <a:solidFill>
+                  <a:srgbClr val="3D5466"/>
+                </a:solidFill>
+                <a:latin typeface="Arial"/>
+              </a:rPr>
+              <a:t>→  Der wichtigste Bedarf ist der, den der Kunde noch nicht ausgesprochen hat.</a:t>
+            </a:r>
+          </a:p>
           <a:p>
             <a:pPr marL="190500" indent="-190500">
               <a:spcBef>
@@ -9316,7 +7481,7 @@
                 </a:solidFill>
                 <a:latin typeface="Arial"/>
               </a:rPr>
-              <a:t>▸  Explizite Bedarfe: Der Kunde benennt klar, was er will. „Ich brauche eine Anschlussfinanzierung für meine Maschine." Explizite Bedarfe entstehen, wenn der Kunde seine Situation analysiert und eine Lösung definiert hat.</a:t>
+              <a:t>▸  Explizite Wünsche bearbeitet jeder Sachbearbeiter.</a:t>
             </a:r>
           </a:p>
           <a:p>
@@ -9335,7 +7500,7 @@
                 </a:solidFill>
                 <a:latin typeface="Arial"/>
               </a:rPr>
-              <a:t>▸  Implizite (latente) Bedarfe: Der Kunde beschreibt ein Problem, einen Schmerz oder eine Unzufriedenheit, ohne eine Lösung zu benennen. „Unsere Abschreibungen sind dieses Jahr sehr hoch." Oder: „Ich mache mir Sorgen wegen der Nachfolge." Latente Bedarfe sind die Grundlage – und oft der eigentliche Grund für das Gespräch.</a:t>
+              <a:t>▸  Latente Bedarfe mit SPIN-Fragen zu heben, unterscheidet den Berater vom Abwickler.</a:t>
             </a:r>
           </a:p>
         </p:txBody>
@@ -9451,7 +7616,7 @@
             <a:avLst/>
           </a:prstGeom>
           <a:solidFill>
-            <a:srgbClr val="FFFFFF"/>
+            <a:srgbClr val="EDEDF3"/>
           </a:solidFill>
           <a:ln>
             <a:noFill/>
@@ -9552,43 +7717,51 @@
                 </a:solidFill>
                 <a:latin typeface="Consolas"/>
               </a:rPr>
-              <a:t>M11  ·  SCHAUBILD</a:t>
-            </a:r>
-          </a:p>
-        </p:txBody>
-      </p:sp>
-      <p:sp>
-        <p:nvSpPr>
-          <p:cNvPr id="5" name="TextBox 4"/>
-          <p:cNvSpPr txBox="1"/>
-          <p:nvPr/>
-        </p:nvSpPr>
-        <p:spPr>
-          <a:xfrm>
-            <a:off x="685800" y="502920"/>
-            <a:ext cx="10817352" cy="594360"/>
-          </a:xfrm>
-          <a:prstGeom prst="rect">
-            <a:avLst/>
-          </a:prstGeom>
-          <a:noFill/>
-        </p:spPr>
-        <p:txBody>
-          <a:bodyPr wrap="square">
-            <a:spAutoFit/>
-          </a:bodyPr>
-          <a:lstStyle/>
-          <a:p>
-            <a:pPr algn="l"/>
-            <a:r>
-              <a:rPr sz="2000" b="1" i="0">
-                <a:solidFill>
-                  <a:srgbClr val="1F2C56"/>
-                </a:solidFill>
-                <a:latin typeface="Arial"/>
-              </a:rPr>
-              <a:t>Eisberg-Modell latente Bedarfe</a:t>
-            </a:r>
+              <a:t>M11  ·  INHALT</a:t>
+            </a:r>
+          </a:p>
+        </p:txBody>
+      </p:sp>
+      <p:sp>
+        <p:nvSpPr>
+          <p:cNvPr id="5" name="Rectangle 4"/>
+          <p:cNvSpPr/>
+          <p:nvPr/>
+        </p:nvSpPr>
+        <p:spPr>
+          <a:xfrm>
+            <a:off x="0" y="1234440"/>
+            <a:ext cx="12188952" cy="12700"/>
+          </a:xfrm>
+          <a:prstGeom prst="rect">
+            <a:avLst/>
+          </a:prstGeom>
+          <a:solidFill>
+            <a:srgbClr val="D8DFE4"/>
+          </a:solidFill>
+          <a:ln>
+            <a:noFill/>
+          </a:ln>
+        </p:spPr>
+        <p:style>
+          <a:lnRef idx="1">
+            <a:schemeClr val="accent1"/>
+          </a:lnRef>
+          <a:fillRef idx="3">
+            <a:schemeClr val="accent1"/>
+          </a:fillRef>
+          <a:effectRef idx="2">
+            <a:schemeClr val="accent1"/>
+          </a:effectRef>
+          <a:fontRef idx="minor">
+            <a:schemeClr val="lt1"/>
+          </a:fontRef>
+        </p:style>
+        <p:txBody>
+          <a:bodyPr rtlCol="0" anchor="ctr"/>
+          <a:lstStyle/>
+          <a:p>
+            <a:pPr algn="ctr"/>
           </a:p>
         </p:txBody>
       </p:sp>
@@ -9600,8 +7773,8 @@
         </p:nvSpPr>
         <p:spPr>
           <a:xfrm>
-            <a:off x="685800" y="1143000"/>
-            <a:ext cx="10817352" cy="25400"/>
+            <a:off x="685800" y="502920"/>
+            <a:ext cx="36576" cy="658368"/>
           </a:xfrm>
           <a:prstGeom prst="rect">
             <a:avLst/>
@@ -9635,33 +7808,124 @@
           </a:p>
         </p:txBody>
       </p:sp>
-      <p:pic>
-        <p:nvPicPr>
-          <p:cNvPr id="7" name="Picture 6" descr="image.png"/>
-          <p:cNvPicPr>
-            <a:picLocks noChangeAspect="1"/>
-          </p:cNvPicPr>
-          <p:nvPr/>
-        </p:nvPicPr>
-        <p:blipFill>
-          <a:blip r:embed="rId2"/>
-          <a:stretch>
-            <a:fillRect/>
-          </a:stretch>
-        </p:blipFill>
-        <p:spPr>
-          <a:xfrm>
-            <a:off x="2554863" y="1325880"/>
-            <a:ext cx="7079225" cy="4937760"/>
-          </a:xfrm>
-          <a:prstGeom prst="rect">
-            <a:avLst/>
-          </a:prstGeom>
-        </p:spPr>
-      </p:pic>
-      <p:sp>
-        <p:nvSpPr>
-          <p:cNvPr id="8" name="Rectangle 7"/>
+      <p:sp>
+        <p:nvSpPr>
+          <p:cNvPr id="7" name="TextBox 6"/>
+          <p:cNvSpPr txBox="1"/>
+          <p:nvPr/>
+        </p:nvSpPr>
+        <p:spPr>
+          <a:xfrm>
+            <a:off x="813816" y="502920"/>
+            <a:ext cx="10634472" cy="685800"/>
+          </a:xfrm>
+          <a:prstGeom prst="rect">
+            <a:avLst/>
+          </a:prstGeom>
+          <a:noFill/>
+        </p:spPr>
+        <p:txBody>
+          <a:bodyPr wrap="square">
+            <a:spAutoFit/>
+          </a:bodyPr>
+          <a:lstStyle/>
+          <a:p>
+            <a:pPr algn="l"/>
+            <a:r>
+              <a:rPr sz="2400" b="1" i="0">
+                <a:solidFill>
+                  <a:srgbClr val="1F2C56"/>
+                </a:solidFill>
+                <a:latin typeface="Arial"/>
+              </a:rPr>
+              <a:t>Das Eisberg-Modell der Kundenbedürfnisse</a:t>
+            </a:r>
+          </a:p>
+        </p:txBody>
+      </p:sp>
+      <p:sp>
+        <p:nvSpPr>
+          <p:cNvPr id="8" name="TextBox 7"/>
+          <p:cNvSpPr txBox="1"/>
+          <p:nvPr/>
+        </p:nvSpPr>
+        <p:spPr>
+          <a:xfrm>
+            <a:off x="685800" y="1417320"/>
+            <a:ext cx="10817352" cy="4892040"/>
+          </a:xfrm>
+          <a:prstGeom prst="rect">
+            <a:avLst/>
+          </a:prstGeom>
+          <a:noFill/>
+        </p:spPr>
+        <p:txBody>
+          <a:bodyPr wrap="square" anchor="ctr">
+            <a:spAutoFit/>
+          </a:bodyPr>
+          <a:lstStyle/>
+          <a:p>
+            <a:pPr marL="177800" indent="-177800">
+              <a:spcBef>
+                <a:spcPts val="600"/>
+              </a:spcBef>
+              <a:spcAft>
+                <a:spcPts val="200"/>
+              </a:spcAft>
+            </a:pPr>
+            <a:r>
+              <a:rPr sz="1200" i="1">
+                <a:solidFill>
+                  <a:srgbClr val="3D5466"/>
+                </a:solidFill>
+                <a:latin typeface="Arial"/>
+              </a:rPr>
+              <a:t>→  Der explizite Wunsch ist die Spitze des Eisbergs – der eigentliche Bedarf liegt darunter.</a:t>
+            </a:r>
+          </a:p>
+          <a:p>
+            <a:pPr marL="190500" indent="-190500">
+              <a:spcBef>
+                <a:spcPts val="400"/>
+              </a:spcBef>
+              <a:spcAft>
+                <a:spcPts val="200"/>
+              </a:spcAft>
+            </a:pPr>
+            <a:r>
+              <a:rPr sz="1300">
+                <a:solidFill>
+                  <a:srgbClr val="3D5466"/>
+                </a:solidFill>
+                <a:latin typeface="Arial"/>
+              </a:rPr>
+              <a:t>▸  Über Wasser: der artikulierte Wunsch (z. B. „ein besserer Zins").</a:t>
+            </a:r>
+          </a:p>
+          <a:p>
+            <a:pPr marL="190500" indent="-190500">
+              <a:spcBef>
+                <a:spcPts val="400"/>
+              </a:spcBef>
+              <a:spcAft>
+                <a:spcPts val="200"/>
+              </a:spcAft>
+            </a:pPr>
+            <a:r>
+              <a:rPr sz="1300">
+                <a:solidFill>
+                  <a:srgbClr val="3D5466"/>
+                </a:solidFill>
+                <a:latin typeface="Arial"/>
+              </a:rPr>
+              <a:t>▸  Unter Wasser: Sorge um Liquidität, Wachstum, Sicherheit, Nachfolge.</a:t>
+            </a:r>
+          </a:p>
+        </p:txBody>
+      </p:sp>
+      <p:sp>
+        <p:nvSpPr>
+          <p:cNvPr id="9" name="Rectangle 8"/>
           <p:cNvSpPr/>
           <p:nvPr/>
         </p:nvSpPr>
@@ -9704,7 +7968,7 @@
       </p:sp>
       <p:sp>
         <p:nvSpPr>
-          <p:cNvPr id="9" name="TextBox 8"/>
+          <p:cNvPr id="10" name="TextBox 9"/>
           <p:cNvSpPr txBox="1"/>
           <p:nvPr/>
         </p:nvSpPr>
@@ -9733,41 +7997,6 @@
                 <a:latin typeface="Consolas"/>
               </a:rPr>
               <a:t>FKB Campus  ·  M11</a:t>
-            </a:r>
-          </a:p>
-        </p:txBody>
-      </p:sp>
-      <p:sp>
-        <p:nvSpPr>
-          <p:cNvPr id="10" name="TextBox 9"/>
-          <p:cNvSpPr txBox="1"/>
-          <p:nvPr/>
-        </p:nvSpPr>
-        <p:spPr>
-          <a:xfrm>
-            <a:off x="7176211" y="6583680"/>
-            <a:ext cx="4326940" cy="256032"/>
-          </a:xfrm>
-          <a:prstGeom prst="rect">
-            <a:avLst/>
-          </a:prstGeom>
-          <a:noFill/>
-        </p:spPr>
-        <p:txBody>
-          <a:bodyPr wrap="none">
-            <a:spAutoFit/>
-          </a:bodyPr>
-          <a:lstStyle/>
-          <a:p>
-            <a:pPr algn="r"/>
-            <a:r>
-              <a:rPr sz="700">
-                <a:solidFill>
-                  <a:srgbClr val="A0B4D2"/>
-                </a:solidFill>
-                <a:latin typeface="Consolas"/>
-              </a:rPr>
-              <a:t>Schaubild</a:t>
             </a:r>
           </a:p>
         </p:txBody>
@@ -9805,7 +8034,7 @@
             <a:avLst/>
           </a:prstGeom>
           <a:solidFill>
-            <a:srgbClr val="EDEDF3"/>
+            <a:srgbClr val="FFFFFF"/>
           </a:solidFill>
           <a:ln>
             <a:noFill/>
@@ -9906,51 +8135,43 @@
                 </a:solidFill>
                 <a:latin typeface="Consolas"/>
               </a:rPr>
-              <a:t>M11  ·  INHALT</a:t>
-            </a:r>
-          </a:p>
-        </p:txBody>
-      </p:sp>
-      <p:sp>
-        <p:nvSpPr>
-          <p:cNvPr id="5" name="Rectangle 4"/>
-          <p:cNvSpPr/>
-          <p:nvPr/>
-        </p:nvSpPr>
-        <p:spPr>
-          <a:xfrm>
-            <a:off x="0" y="1234440"/>
-            <a:ext cx="12188952" cy="12700"/>
-          </a:xfrm>
-          <a:prstGeom prst="rect">
-            <a:avLst/>
-          </a:prstGeom>
-          <a:solidFill>
-            <a:srgbClr val="D8DFE4"/>
-          </a:solidFill>
-          <a:ln>
-            <a:noFill/>
-          </a:ln>
-        </p:spPr>
-        <p:style>
-          <a:lnRef idx="1">
-            <a:schemeClr val="accent1"/>
-          </a:lnRef>
-          <a:fillRef idx="3">
-            <a:schemeClr val="accent1"/>
-          </a:fillRef>
-          <a:effectRef idx="2">
-            <a:schemeClr val="accent1"/>
-          </a:effectRef>
-          <a:fontRef idx="minor">
-            <a:schemeClr val="lt1"/>
-          </a:fontRef>
-        </p:style>
-        <p:txBody>
-          <a:bodyPr rtlCol="0" anchor="ctr"/>
-          <a:lstStyle/>
-          <a:p>
-            <a:pPr algn="ctr"/>
+              <a:t>M11  ·  SCHAUBILD</a:t>
+            </a:r>
+          </a:p>
+        </p:txBody>
+      </p:sp>
+      <p:sp>
+        <p:nvSpPr>
+          <p:cNvPr id="5" name="TextBox 4"/>
+          <p:cNvSpPr txBox="1"/>
+          <p:nvPr/>
+        </p:nvSpPr>
+        <p:spPr>
+          <a:xfrm>
+            <a:off x="685800" y="502920"/>
+            <a:ext cx="10817352" cy="594360"/>
+          </a:xfrm>
+          <a:prstGeom prst="rect">
+            <a:avLst/>
+          </a:prstGeom>
+          <a:noFill/>
+        </p:spPr>
+        <p:txBody>
+          <a:bodyPr wrap="square">
+            <a:spAutoFit/>
+          </a:bodyPr>
+          <a:lstStyle/>
+          <a:p>
+            <a:pPr algn="l"/>
+            <a:r>
+              <a:rPr sz="2000" b="1" i="0">
+                <a:solidFill>
+                  <a:srgbClr val="1F2C56"/>
+                </a:solidFill>
+                <a:latin typeface="Arial"/>
+              </a:rPr>
+              <a:t>Das Eisberg-Modell latenter Bedarfe</a:t>
+            </a:r>
           </a:p>
         </p:txBody>
       </p:sp>
@@ -9962,8 +8183,8 @@
         </p:nvSpPr>
         <p:spPr>
           <a:xfrm>
-            <a:off x="685800" y="502920"/>
-            <a:ext cx="36576" cy="658368"/>
+            <a:off x="685800" y="1143000"/>
+            <a:ext cx="10817352" cy="25400"/>
           </a:xfrm>
           <a:prstGeom prst="rect">
             <a:avLst/>
@@ -9997,181 +8218,33 @@
           </a:p>
         </p:txBody>
       </p:sp>
-      <p:sp>
-        <p:nvSpPr>
-          <p:cNvPr id="7" name="TextBox 6"/>
-          <p:cNvSpPr txBox="1"/>
-          <p:nvPr/>
-        </p:nvSpPr>
-        <p:spPr>
-          <a:xfrm>
-            <a:off x="813816" y="502920"/>
-            <a:ext cx="10634472" cy="685800"/>
-          </a:xfrm>
-          <a:prstGeom prst="rect">
-            <a:avLst/>
-          </a:prstGeom>
-          <a:noFill/>
-        </p:spPr>
-        <p:txBody>
-          <a:bodyPr wrap="square">
-            <a:spAutoFit/>
-          </a:bodyPr>
-          <a:lstStyle/>
-          <a:p>
-            <a:pPr algn="l"/>
-            <a:r>
-              <a:rPr sz="2400" b="1" i="0">
-                <a:solidFill>
-                  <a:srgbClr val="1F2C56"/>
-                </a:solidFill>
-                <a:latin typeface="Arial"/>
-              </a:rPr>
-              <a:t>Warum Kunden latente Bedarfe nicht artikulieren</a:t>
-            </a:r>
-          </a:p>
-        </p:txBody>
-      </p:sp>
-      <p:sp>
-        <p:nvSpPr>
-          <p:cNvPr id="8" name="TextBox 7"/>
-          <p:cNvSpPr txBox="1"/>
-          <p:nvPr/>
-        </p:nvSpPr>
-        <p:spPr>
-          <a:xfrm>
-            <a:off x="685800" y="1417320"/>
-            <a:ext cx="10817352" cy="4892040"/>
-          </a:xfrm>
-          <a:prstGeom prst="rect">
-            <a:avLst/>
-          </a:prstGeom>
-          <a:noFill/>
-        </p:spPr>
-        <p:txBody>
-          <a:bodyPr wrap="square">
-            <a:spAutoFit/>
-          </a:bodyPr>
-          <a:lstStyle/>
-          <a:p>
-            <a:pPr marL="190500" indent="-190500">
-              <a:spcBef>
-                <a:spcPts val="400"/>
-              </a:spcBef>
-              <a:spcAft>
-                <a:spcPts val="200"/>
-              </a:spcAft>
-            </a:pPr>
-            <a:r>
-              <a:rPr sz="1300">
-                <a:solidFill>
-                  <a:srgbClr val="3D5466"/>
-                </a:solidFill>
-                <a:latin typeface="Arial"/>
-              </a:rPr>
-              <a:t>▸  Es gibt vier Hauptgründe, warum Kunden ihre eigentlichen Bedarfe nicht spontan nennen (praxisbasiert; vgl. Rackham, 1988 , S. 57–62):</a:t>
-            </a:r>
-          </a:p>
-          <a:p>
-            <a:pPr marL="190500" indent="-190500">
-              <a:spcBef>
-                <a:spcPts val="400"/>
-              </a:spcBef>
-              <a:spcAft>
-                <a:spcPts val="200"/>
-              </a:spcAft>
-            </a:pPr>
-            <a:r>
-              <a:rPr sz="1300">
-                <a:solidFill>
-                  <a:srgbClr val="3D5466"/>
-                </a:solidFill>
-                <a:latin typeface="Arial"/>
-              </a:rPr>
-              <a:t>▸  Unbewusstheit: Der Bedarf ist noch nicht als solcher erkannt. Der Kunde spürt das Problem, hat es aber nicht als lösungswürdig eingeordnet.</a:t>
-            </a:r>
-          </a:p>
-          <a:p>
-            <a:pPr marL="190500" indent="-190500">
-              <a:spcBef>
-                <a:spcPts val="400"/>
-              </a:spcBef>
-              <a:spcAft>
-                <a:spcPts val="200"/>
-              </a:spcAft>
-            </a:pPr>
-            <a:r>
-              <a:rPr sz="1300">
-                <a:solidFill>
-                  <a:srgbClr val="3D5466"/>
-                </a:solidFill>
-                <a:latin typeface="Arial"/>
-              </a:rPr>
-              <a:t>▸  Schambarriere: Sensitive Themen wie Nachfolge, Unternehmenskrise oder Privatsphäre werden nicht freiwillig angesprochen.</a:t>
-            </a:r>
-          </a:p>
-          <a:p>
-            <a:pPr marL="190500" indent="-190500">
-              <a:spcBef>
-                <a:spcPts val="400"/>
-              </a:spcBef>
-              <a:spcAft>
-                <a:spcPts val="200"/>
-              </a:spcAft>
-            </a:pPr>
-            <a:r>
-              <a:rPr sz="1300">
-                <a:solidFill>
-                  <a:srgbClr val="3D5466"/>
-                </a:solidFill>
-                <a:latin typeface="Arial"/>
-              </a:rPr>
-              <a:t>▸  Fehlende Sicherheit: Der Kunde weiß nicht, ob der Berater kompetent genug ist für das eigentliche Thema. Im Volksbankenalltag kommt ein verstärkender Faktor hinzu: Häufige Beraterwechsel. Wer innerhalb von sechs Jahren den vierten Berater bekommt, hat gelernt, sensible Themen wie Nachfolge oder Unternehmenskrise nicht mehr anzusprechen – das Vertrauen für diese Ebene muss jedes Mal neu aufgebaut werden. Praxistipp: Eigene Erfahrungen kurz einbringen öffnet schneller als jede Frage – „Ich habe das bei einem anderen Kunden ähnlich erlebt, wie er das gelöst hat, war interessant…" signalisiert Kompetenz und schafft Vertrautheit.</a:t>
-            </a:r>
-          </a:p>
-          <a:p>
-            <a:pPr marL="190500" indent="-190500">
-              <a:spcBef>
-                <a:spcPts val="400"/>
-              </a:spcBef>
-              <a:spcAft>
-                <a:spcPts val="200"/>
-              </a:spcAft>
-            </a:pPr>
-            <a:r>
-              <a:rPr sz="1300">
-                <a:solidFill>
-                  <a:srgbClr val="3D5466"/>
-                </a:solidFill>
-                <a:latin typeface="Arial"/>
-              </a:rPr>
-              <a:t>▸  Gewohnheit: Der Kunde ist es gewohnt, dass Bankgespräche Produktgespräche sind – er stellt sich selbst anders ein.</a:t>
-            </a:r>
-          </a:p>
-          <a:p>
-            <a:pPr marL="190500" indent="-190500">
-              <a:spcBef>
-                <a:spcPts val="400"/>
-              </a:spcBef>
-              <a:spcAft>
-                <a:spcPts val="200"/>
-              </a:spcAft>
-            </a:pPr>
-            <a:r>
-              <a:rPr sz="1300">
-                <a:solidFill>
-                  <a:srgbClr val="3D5466"/>
-                </a:solidFill>
-                <a:latin typeface="Arial"/>
-              </a:rPr>
-              <a:t>▸  Der Berater, der latente Bedarfe erkennen will, muss aktiv dazu einladen: durch offene Haltung, gezielte Fragen und echtes Zuhören.</a:t>
-            </a:r>
-          </a:p>
-        </p:txBody>
-      </p:sp>
-      <p:sp>
-        <p:nvSpPr>
-          <p:cNvPr id="9" name="Rectangle 8"/>
+      <p:pic>
+        <p:nvPicPr>
+          <p:cNvPr id="7" name="Picture 6" descr="image.png"/>
+          <p:cNvPicPr>
+            <a:picLocks noChangeAspect="1"/>
+          </p:cNvPicPr>
+          <p:nvPr/>
+        </p:nvPicPr>
+        <p:blipFill>
+          <a:blip r:embed="rId2"/>
+          <a:stretch>
+            <a:fillRect/>
+          </a:stretch>
+        </p:blipFill>
+        <p:spPr>
+          <a:xfrm>
+            <a:off x="2554863" y="1325880"/>
+            <a:ext cx="7079225" cy="4937760"/>
+          </a:xfrm>
+          <a:prstGeom prst="rect">
+            <a:avLst/>
+          </a:prstGeom>
+        </p:spPr>
+      </p:pic>
+      <p:sp>
+        <p:nvSpPr>
+          <p:cNvPr id="8" name="Rectangle 7"/>
           <p:cNvSpPr/>
           <p:nvPr/>
         </p:nvSpPr>
@@ -10214,7 +8287,7 @@
       </p:sp>
       <p:sp>
         <p:nvSpPr>
-          <p:cNvPr id="10" name="TextBox 9"/>
+          <p:cNvPr id="9" name="TextBox 8"/>
           <p:cNvSpPr txBox="1"/>
           <p:nvPr/>
         </p:nvSpPr>
@@ -10243,6 +8316,41 @@
                 <a:latin typeface="Consolas"/>
               </a:rPr>
               <a:t>FKB Campus  ·  M11</a:t>
+            </a:r>
+          </a:p>
+        </p:txBody>
+      </p:sp>
+      <p:sp>
+        <p:nvSpPr>
+          <p:cNvPr id="10" name="TextBox 9"/>
+          <p:cNvSpPr txBox="1"/>
+          <p:nvPr/>
+        </p:nvSpPr>
+        <p:spPr>
+          <a:xfrm>
+            <a:off x="7176211" y="6583680"/>
+            <a:ext cx="4326940" cy="256032"/>
+          </a:xfrm>
+          <a:prstGeom prst="rect">
+            <a:avLst/>
+          </a:prstGeom>
+          <a:noFill/>
+        </p:spPr>
+        <p:txBody>
+          <a:bodyPr wrap="none">
+            <a:spAutoFit/>
+          </a:bodyPr>
+          <a:lstStyle/>
+          <a:p>
+            <a:pPr algn="r"/>
+            <a:r>
+              <a:rPr sz="700">
+                <a:solidFill>
+                  <a:srgbClr val="A0B4D2"/>
+                </a:solidFill>
+                <a:latin typeface="Consolas"/>
+              </a:rPr>
+              <a:t>Schaubild</a:t>
             </a:r>
           </a:p>
         </p:txBody>
@@ -10502,7 +8610,7 @@
                 </a:solidFill>
                 <a:latin typeface="Arial"/>
               </a:rPr>
-              <a:t>Typische latente Bedarfsfelder im Firmenkunden-Alltag</a:t>
+              <a:t>SPIN: mit Fragen in die Tiefe</a:t>
             </a:r>
           </a:p>
         </p:txBody>
@@ -10528,6 +8636,25 @@
             <a:spAutoFit/>
           </a:bodyPr>
           <a:lstStyle/>
+          <a:p>
+            <a:pPr marL="177800" indent="-177800">
+              <a:spcBef>
+                <a:spcPts val="600"/>
+              </a:spcBef>
+              <a:spcAft>
+                <a:spcPts val="200"/>
+              </a:spcAft>
+            </a:pPr>
+            <a:r>
+              <a:rPr sz="1200" i="1">
+                <a:solidFill>
+                  <a:srgbClr val="3D5466"/>
+                </a:solidFill>
+                <a:latin typeface="Arial"/>
+              </a:rPr>
+              <a:t>→  SPIN führt in drei Tiefen-Ebenen vom expliziten Wunsch zum latenten Bedarf.</a:t>
+            </a:r>
+          </a:p>
           <a:p>
             <a:pPr marL="190500" indent="-190500">
               <a:spcBef>
@@ -10544,7 +8671,7 @@
                 </a:solidFill>
                 <a:latin typeface="Arial"/>
               </a:rPr>
-              <a:t>▸  Ein Berater braucht ein inneres Radar: Worauf soll ich achten? Die folgende Übersicht zeigt die vier häufigsten Felder – mit typischen Kundensignalen und passendem Gesprächseinstieg:</a:t>
+              <a:t>▸  Situation und Problem klären, Implikation aufzeigen, Nutzen herausarbeiten.</a:t>
             </a:r>
           </a:p>
           <a:p>
@@ -10563,26 +8690,7 @@
                 </a:solidFill>
                 <a:latin typeface="Arial"/>
               </a:rPr>
-              <a:t>▸  ## 4.2 SPIN – Das Fragetechnik-System für tiefe Bedarfe</a:t>
-            </a:r>
-          </a:p>
-          <a:p>
-            <a:pPr marL="190500" indent="-190500">
-              <a:spcBef>
-                <a:spcPts val="400"/>
-              </a:spcBef>
-              <a:spcAft>
-                <a:spcPts val="200"/>
-              </a:spcAft>
-            </a:pPr>
-            <a:r>
-              <a:rPr sz="1300">
-                <a:solidFill>
-                  <a:srgbClr val="3D5466"/>
-                </a:solidFill>
-                <a:latin typeface="Arial"/>
-              </a:rPr>
-              <a:t>▸  Rackham (1988) entwickelte das SPIN-Modell auf Basis empirischer Gesprächsanalysen. Die vier Fragetypen führen den Kunden von der Oberfläche in die Tiefe:</a:t>
+              <a:t>▸  Die vier Signalkanäle (Wortwahl, Betonung, Körpersprache, Auslassung) lesen.</a:t>
             </a:r>
           </a:p>
         </p:txBody>
@@ -10698,7 +8806,7 @@
             <a:avLst/>
           </a:prstGeom>
           <a:solidFill>
-            <a:srgbClr val="EDEDF3"/>
+            <a:srgbClr val="1F2C56"/>
           </a:solidFill>
           <a:ln>
             <a:noFill/>
@@ -10728,57 +8836,14 @@
       </p:sp>
       <p:sp>
         <p:nvSpPr>
-          <p:cNvPr id="3" name="Rectangle 2"/>
-          <p:cNvSpPr/>
-          <p:nvPr/>
-        </p:nvSpPr>
-        <p:spPr>
-          <a:xfrm>
-            <a:off x="0" y="0"/>
-            <a:ext cx="12188952" cy="50292"/>
-          </a:xfrm>
-          <a:prstGeom prst="rect">
-            <a:avLst/>
-          </a:prstGeom>
-          <a:solidFill>
-            <a:srgbClr val="1F2C56"/>
-          </a:solidFill>
-          <a:ln>
-            <a:noFill/>
-          </a:ln>
-        </p:spPr>
-        <p:style>
-          <a:lnRef idx="1">
-            <a:schemeClr val="accent1"/>
-          </a:lnRef>
-          <a:fillRef idx="3">
-            <a:schemeClr val="accent1"/>
-          </a:fillRef>
-          <a:effectRef idx="2">
-            <a:schemeClr val="accent1"/>
-          </a:effectRef>
-          <a:fontRef idx="minor">
-            <a:schemeClr val="lt1"/>
-          </a:fontRef>
-        </p:style>
-        <p:txBody>
-          <a:bodyPr rtlCol="0" anchor="ctr"/>
-          <a:lstStyle/>
-          <a:p>
-            <a:pPr algn="ctr"/>
-          </a:p>
-        </p:txBody>
-      </p:sp>
-      <p:sp>
-        <p:nvSpPr>
-          <p:cNvPr id="4" name="TextBox 3"/>
+          <p:cNvPr id="3" name="TextBox 2"/>
           <p:cNvSpPr txBox="1"/>
           <p:nvPr/>
         </p:nvSpPr>
         <p:spPr>
           <a:xfrm>
-            <a:off x="685800" y="109728"/>
-            <a:ext cx="10817352" cy="228600"/>
+            <a:off x="685800" y="2377440"/>
+            <a:ext cx="10817352" cy="365760"/>
           </a:xfrm>
           <a:prstGeom prst="rect">
             <a:avLst/>
@@ -10793,70 +8858,27 @@
           <a:p>
             <a:pPr algn="l"/>
             <a:r>
-              <a:rPr sz="750">
-                <a:solidFill>
-                  <a:srgbClr val="78808C"/>
+              <a:rPr sz="1200">
+                <a:solidFill>
+                  <a:srgbClr val="D9C089"/>
                 </a:solidFill>
                 <a:latin typeface="Consolas"/>
               </a:rPr>
-              <a:t>M11  ·  INHALT</a:t>
-            </a:r>
-          </a:p>
-        </p:txBody>
-      </p:sp>
-      <p:sp>
-        <p:nvSpPr>
-          <p:cNvPr id="5" name="Rectangle 4"/>
+              <a:t>FALLARBEIT</a:t>
+            </a:r>
+          </a:p>
+        </p:txBody>
+      </p:sp>
+      <p:sp>
+        <p:nvSpPr>
+          <p:cNvPr id="4" name="Rectangle 3"/>
           <p:cNvSpPr/>
           <p:nvPr/>
         </p:nvSpPr>
         <p:spPr>
           <a:xfrm>
-            <a:off x="0" y="1234440"/>
-            <a:ext cx="12188952" cy="12700"/>
-          </a:xfrm>
-          <a:prstGeom prst="rect">
-            <a:avLst/>
-          </a:prstGeom>
-          <a:solidFill>
-            <a:srgbClr val="D8DFE4"/>
-          </a:solidFill>
-          <a:ln>
-            <a:noFill/>
-          </a:ln>
-        </p:spPr>
-        <p:style>
-          <a:lnRef idx="1">
-            <a:schemeClr val="accent1"/>
-          </a:lnRef>
-          <a:fillRef idx="3">
-            <a:schemeClr val="accent1"/>
-          </a:fillRef>
-          <a:effectRef idx="2">
-            <a:schemeClr val="accent1"/>
-          </a:effectRef>
-          <a:fontRef idx="minor">
-            <a:schemeClr val="lt1"/>
-          </a:fontRef>
-        </p:style>
-        <p:txBody>
-          <a:bodyPr rtlCol="0" anchor="ctr"/>
-          <a:lstStyle/>
-          <a:p>
-            <a:pPr algn="ctr"/>
-          </a:p>
-        </p:txBody>
-      </p:sp>
-      <p:sp>
-        <p:nvSpPr>
-          <p:cNvPr id="6" name="Rectangle 5"/>
-          <p:cNvSpPr/>
-          <p:nvPr/>
-        </p:nvSpPr>
-        <p:spPr>
-          <a:xfrm>
-            <a:off x="685800" y="502920"/>
-            <a:ext cx="36576" cy="658368"/>
+            <a:off x="685800" y="2788920"/>
+            <a:ext cx="548640" cy="38100"/>
           </a:xfrm>
           <a:prstGeom prst="rect">
             <a:avLst/>
@@ -10892,14 +8914,14 @@
       </p:sp>
       <p:sp>
         <p:nvSpPr>
-          <p:cNvPr id="7" name="TextBox 6"/>
+          <p:cNvPr id="5" name="TextBox 4"/>
           <p:cNvSpPr txBox="1"/>
           <p:nvPr/>
         </p:nvSpPr>
         <p:spPr>
           <a:xfrm>
-            <a:off x="813816" y="502920"/>
-            <a:ext cx="10634472" cy="685800"/>
+            <a:off x="685800" y="3017520"/>
+            <a:ext cx="10817352" cy="1463040"/>
           </a:xfrm>
           <a:prstGeom prst="rect">
             <a:avLst/>
@@ -10914,27 +8936,27 @@
           <a:p>
             <a:pPr algn="l"/>
             <a:r>
-              <a:rPr sz="2400" b="1" i="0">
-                <a:solidFill>
-                  <a:srgbClr val="1F2C56"/>
+              <a:rPr sz="4000" b="1" i="0">
+                <a:solidFill>
+                  <a:srgbClr val="FFFFFF"/>
                 </a:solidFill>
                 <a:latin typeface="Arial"/>
               </a:rPr>
-              <a:t>Fragetechnik in der Praxis: Drei Tiefen-Ebenen</a:t>
-            </a:r>
-          </a:p>
-        </p:txBody>
-      </p:sp>
-      <p:sp>
-        <p:nvSpPr>
-          <p:cNvPr id="8" name="TextBox 7"/>
+              <a:t>Praxiscase &amp; Rollenspiel</a:t>
+            </a:r>
+          </a:p>
+        </p:txBody>
+      </p:sp>
+      <p:sp>
+        <p:nvSpPr>
+          <p:cNvPr id="6" name="TextBox 5"/>
           <p:cNvSpPr txBox="1"/>
           <p:nvPr/>
         </p:nvSpPr>
         <p:spPr>
           <a:xfrm>
-            <a:off x="685800" y="1417320"/>
-            <a:ext cx="10817352" cy="4892040"/>
+            <a:off x="685800" y="4480560"/>
+            <a:ext cx="8653881" cy="1280160"/>
           </a:xfrm>
           <a:prstGeom prst="rect">
             <a:avLst/>
@@ -10947,288 +8969,29 @@
           </a:bodyPr>
           <a:lstStyle/>
           <a:p>
-            <a:pPr marL="190500" indent="-190500">
-              <a:spcBef>
-                <a:spcPts val="400"/>
-              </a:spcBef>
-              <a:spcAft>
-                <a:spcPts val="200"/>
-              </a:spcAft>
-            </a:pPr>
-            <a:r>
-              <a:rPr sz="1300">
-                <a:solidFill>
-                  <a:srgbClr val="3D5466"/>
+            <a:pPr algn="l"/>
+            <a:r>
+              <a:rPr sz="1600" b="0" i="0">
+                <a:solidFill>
+                  <a:srgbClr val="C8D2E6"/>
                 </a:solidFill>
                 <a:latin typeface="Arial"/>
               </a:rPr>
-              <a:t>▸  Latente Bedarfe liegen oft unter zwei oder drei Gesprächsschichten. Eine einfache Orientierung:</a:t>
-            </a:r>
-          </a:p>
-          <a:p>
-            <a:pPr marL="190500" indent="-190500">
-              <a:spcBef>
-                <a:spcPts val="400"/>
-              </a:spcBef>
-              <a:spcAft>
-                <a:spcPts val="200"/>
-              </a:spcAft>
-            </a:pPr>
-            <a:r>
-              <a:rPr sz="1300">
-                <a:solidFill>
-                  <a:srgbClr val="3D5466"/>
-                </a:solidFill>
-                <a:latin typeface="Arial"/>
-              </a:rPr>
-              <a:t>▸  Ebene 1 – Thema (Was ist das Gesprächsthema?)</a:t>
-            </a:r>
-          </a:p>
-          <a:p>
-            <a:pPr marL="177800" indent="-177800">
-              <a:spcBef>
-                <a:spcPts val="600"/>
-              </a:spcBef>
-              <a:spcAft>
-                <a:spcPts val="200"/>
-              </a:spcAft>
-            </a:pPr>
-            <a:r>
-              <a:rPr sz="1200" i="1">
-                <a:solidFill>
-                  <a:srgbClr val="3D5466"/>
-                </a:solidFill>
-                <a:latin typeface="Arial"/>
-              </a:rPr>
-              <a:t>→  „Wie läuft das Geschäft aktuell?"</a:t>
-            </a:r>
-          </a:p>
-          <a:p>
-            <a:pPr marL="190500" indent="-190500">
-              <a:spcBef>
-                <a:spcPts val="400"/>
-              </a:spcBef>
-              <a:spcAft>
-                <a:spcPts val="200"/>
-              </a:spcAft>
-            </a:pPr>
-            <a:r>
-              <a:rPr sz="1300">
-                <a:solidFill>
-                  <a:srgbClr val="3D5466"/>
-                </a:solidFill>
-                <a:latin typeface="Arial"/>
-              </a:rPr>
-              <a:t>▸  Ebene 2 – Problem (Wo drückt der Schuh?)</a:t>
-            </a:r>
-          </a:p>
-          <a:p>
-            <a:pPr marL="177800" indent="-177800">
-              <a:spcBef>
-                <a:spcPts val="600"/>
-              </a:spcBef>
-              <a:spcAft>
-                <a:spcPts val="200"/>
-              </a:spcAft>
-            </a:pPr>
-            <a:r>
-              <a:rPr sz="1200" i="1">
-                <a:solidFill>
-                  <a:srgbClr val="3D5466"/>
-                </a:solidFill>
-                <a:latin typeface="Arial"/>
-              </a:rPr>
-              <a:t>→  „Sie sagten, die Personalkosten steigen. Was steckt dahinter?"</a:t>
-            </a:r>
-          </a:p>
-          <a:p>
-            <a:pPr marL="190500" indent="-190500">
-              <a:spcBef>
-                <a:spcPts val="400"/>
-              </a:spcBef>
-              <a:spcAft>
-                <a:spcPts val="200"/>
-              </a:spcAft>
-            </a:pPr>
-            <a:r>
-              <a:rPr sz="1300">
-                <a:solidFill>
-                  <a:srgbClr val="3D5466"/>
-                </a:solidFill>
-                <a:latin typeface="Arial"/>
-              </a:rPr>
-              <a:t>▸  Ebene 3 – Bedeutung (Was steht auf dem Spiel?)</a:t>
-            </a:r>
-          </a:p>
-          <a:p>
-            <a:pPr marL="177800" indent="-177800">
-              <a:spcBef>
-                <a:spcPts val="600"/>
-              </a:spcBef>
-              <a:spcAft>
-                <a:spcPts val="200"/>
-              </a:spcAft>
-            </a:pPr>
-            <a:r>
-              <a:rPr sz="1200" i="1">
-                <a:solidFill>
-                  <a:srgbClr val="3D5466"/>
-                </a:solidFill>
-                <a:latin typeface="Arial"/>
-              </a:rPr>
-              <a:t>→  „Wenn sich das fortsetzt: Was bedeutet das für Ihre Pläne für die nächsten fünf Jahre?"</a:t>
-            </a:r>
-          </a:p>
-          <a:p>
-            <a:pPr marL="190500" indent="-190500">
-              <a:spcBef>
-                <a:spcPts val="400"/>
-              </a:spcBef>
-              <a:spcAft>
-                <a:spcPts val="200"/>
-              </a:spcAft>
-            </a:pPr>
-            <a:r>
-              <a:rPr sz="1300">
-                <a:solidFill>
-                  <a:srgbClr val="3D5466"/>
-                </a:solidFill>
-                <a:latin typeface="Arial"/>
-              </a:rPr>
-              <a:t>▸  Erst auf Ebene 3 wird der latente Bedarf sichtbar – und damit auch, welches Produkt oder welche Lösung wirklich passt.</a:t>
-            </a:r>
-          </a:p>
-          <a:p>
-            <a:pPr marL="190500" indent="-190500">
-              <a:spcBef>
-                <a:spcPts val="400"/>
-              </a:spcBef>
-              <a:spcAft>
-                <a:spcPts val="200"/>
-              </a:spcAft>
-            </a:pPr>
-            <a:r>
-              <a:rPr sz="1300">
-                <a:solidFill>
-                  <a:srgbClr val="3D5466"/>
-                </a:solidFill>
-                <a:latin typeface="Arial"/>
-              </a:rPr>
-              <a:t>▸  ## 4.3 Signale erkennen: Die vier Kanäle</a:t>
-            </a:r>
-          </a:p>
-          <a:p>
-            <a:pPr marL="190500" indent="-190500">
-              <a:spcBef>
-                <a:spcPts val="400"/>
-              </a:spcBef>
-              <a:spcAft>
-                <a:spcPts val="200"/>
-              </a:spcAft>
-            </a:pPr>
-            <a:r>
-              <a:rPr sz="1300">
-                <a:solidFill>
-                  <a:srgbClr val="3D5466"/>
-                </a:solidFill>
-                <a:latin typeface="Arial"/>
-              </a:rPr>
-              <a:t>▸  Kunden kommunizieren latente Bedarfe auf vier Kanälen gleichzeitig (Watzlawick et al., 1967; Schulz von Thun, 1981). Wer nur den Sachkanal hört, verpasst 75 % der Information.</a:t>
-            </a:r>
-          </a:p>
-          <a:p>
-            <a:pPr marL="190500" indent="-190500">
-              <a:spcBef>
-                <a:spcPts val="400"/>
-              </a:spcBef>
-              <a:spcAft>
-                <a:spcPts val="200"/>
-              </a:spcAft>
-            </a:pPr>
-            <a:r>
-              <a:rPr sz="1300">
-                <a:solidFill>
-                  <a:srgbClr val="3D5466"/>
-                </a:solidFill>
-                <a:latin typeface="Arial"/>
-              </a:rPr>
-              <a:t>▸  Paraverbale Signale: Pausen, Zögern, plötzlich leiser werden, Themenwechsel nach Nachfrage.</a:t>
-            </a:r>
-          </a:p>
-          <a:p>
-            <a:pPr marL="190500" indent="-190500">
-              <a:spcBef>
-                <a:spcPts val="400"/>
-              </a:spcBef>
-              <a:spcAft>
-                <a:spcPts val="200"/>
-              </a:spcAft>
-            </a:pPr>
-            <a:r>
-              <a:rPr sz="1300">
-                <a:solidFill>
-                  <a:srgbClr val="3D5466"/>
-                </a:solidFill>
-                <a:latin typeface="Arial"/>
-              </a:rPr>
-              <a:t>▸  Nonverbale Signale: Abwenden, kurzes Lächeln das nicht bis zu den Augen geht, angespannte Körperhaltung beim bestimmten Thema.</a:t>
-            </a:r>
-          </a:p>
-        </p:txBody>
-      </p:sp>
-      <p:sp>
-        <p:nvSpPr>
-          <p:cNvPr id="9" name="Rectangle 8"/>
-          <p:cNvSpPr/>
-          <p:nvPr/>
-        </p:nvSpPr>
-        <p:spPr>
-          <a:xfrm>
-            <a:off x="0" y="6510528"/>
-            <a:ext cx="12188952" cy="347472"/>
-          </a:xfrm>
-          <a:prstGeom prst="rect">
-            <a:avLst/>
-          </a:prstGeom>
-          <a:solidFill>
-            <a:srgbClr val="0A1937"/>
-          </a:solidFill>
-          <a:ln>
-            <a:noFill/>
-          </a:ln>
-        </p:spPr>
-        <p:style>
-          <a:lnRef idx="1">
-            <a:schemeClr val="accent1"/>
-          </a:lnRef>
-          <a:fillRef idx="3">
-            <a:schemeClr val="accent1"/>
-          </a:fillRef>
-          <a:effectRef idx="2">
-            <a:schemeClr val="accent1"/>
-          </a:effectRef>
-          <a:fontRef idx="minor">
-            <a:schemeClr val="lt1"/>
-          </a:fontRef>
-        </p:style>
-        <p:txBody>
-          <a:bodyPr rtlCol="0" anchor="ctr"/>
-          <a:lstStyle/>
-          <a:p>
-            <a:pPr algn="ctr"/>
-          </a:p>
-        </p:txBody>
-      </p:sp>
-      <p:sp>
-        <p:nvSpPr>
-          <p:cNvPr id="10" name="TextBox 9"/>
+              <a:t>Hinter dem Zinsgespräch den eigentlichen Bedarf finden.</a:t>
+            </a:r>
+          </a:p>
+        </p:txBody>
+      </p:sp>
+      <p:sp>
+        <p:nvSpPr>
+          <p:cNvPr id="7" name="TextBox 6"/>
           <p:cNvSpPr txBox="1"/>
           <p:nvPr/>
         </p:nvSpPr>
         <p:spPr>
           <a:xfrm>
-            <a:off x="685800" y="6583680"/>
-            <a:ext cx="6490411" cy="256032"/>
+            <a:off x="685800" y="6355080"/>
+            <a:ext cx="10817352" cy="274320"/>
           </a:xfrm>
           <a:prstGeom prst="rect">
             <a:avLst/>
@@ -11245,7 +9008,7 @@
             <a:r>
               <a:rPr sz="700">
                 <a:solidFill>
-                  <a:srgbClr val="A0B4D2"/>
+                  <a:srgbClr val="8CA0C3"/>
                 </a:solidFill>
                 <a:latin typeface="Consolas"/>
               </a:rPr>

</xml_diff>